<commit_message>
📄 Add plan file: plan_120.pptx
</commit_message>
<xml_diff>
--- a/plans/plan_120.pptx
+++ b/plans/plan_120.pptx
@@ -3235,7 +3235,7 @@
                 <a:solidFill>
                   <a:srgbClr val="FFB87A"/>
                 </a:solidFill>
-                <a:latin typeface="WenQuanYi Micro Hei"/>
+                <a:latin typeface="Microsoft YaHei"/>
               </a:rPr>
               <a:t>MEITUAN · 餐饮数字化经营解决方案</a:t>
             </a:r>
@@ -3280,7 +3280,7 @@
                 <a:solidFill>
                   <a:srgbClr val="FFFFFF"/>
                 </a:solidFill>
-                <a:latin typeface="WenQuanYi Micro Hei"/>
+                <a:latin typeface="Microsoft YaHei"/>
               </a:rPr>
               <a:t>新豪仔小龙虾</a:t>
             </a:r>
@@ -3302,7 +3302,7 @@
                 <a:solidFill>
                   <a:srgbClr val="FF9A4A"/>
                 </a:solidFill>
-                <a:latin typeface="WenQuanYi Micro Hei"/>
+                <a:latin typeface="Microsoft YaHei"/>
               </a:rPr>
               <a:t>烧烤 · 融合菜</a:t>
             </a:r>
@@ -3347,7 +3347,7 @@
                 <a:solidFill>
                   <a:srgbClr val="CFDCEC"/>
                 </a:solidFill>
-                <a:latin typeface="WenQuanYi Micro Hei"/>
+                <a:latin typeface="Microsoft YaHei"/>
               </a:rPr>
               <a:t>新店开业冷启动 × 公私域一体化运营方案</a:t>
             </a:r>
@@ -3436,7 +3436,7 @@
                 <a:solidFill>
                   <a:srgbClr val="FFFFFF"/>
                 </a:solidFill>
-                <a:latin typeface="WenQuanYi Micro Hei"/>
+                <a:latin typeface="Microsoft YaHei"/>
               </a:rPr>
               <a:t>📍杭州滨江·金铂湾</a:t>
             </a:r>
@@ -3525,7 +3525,7 @@
                 <a:solidFill>
                   <a:srgbClr val="FFFFFF"/>
                 </a:solidFill>
-                <a:latin typeface="WenQuanYi Micro Hei"/>
+                <a:latin typeface="Microsoft YaHei"/>
               </a:rPr>
               <a:t>🍤小龙虾+烧烤融合</a:t>
             </a:r>
@@ -3614,7 +3614,7 @@
                 <a:solidFill>
                   <a:srgbClr val="FFFFFF"/>
                 </a:solidFill>
-                <a:latin typeface="WenQuanYi Micro Hei"/>
+                <a:latin typeface="Microsoft YaHei"/>
               </a:rPr>
               <a:t>👥人均¥80</a:t>
             </a:r>
@@ -3703,7 +3703,7 @@
                 <a:solidFill>
                   <a:srgbClr val="FFFFFF"/>
                 </a:solidFill>
-                <a:latin typeface="WenQuanYi Micro Hei"/>
+                <a:latin typeface="Microsoft YaHei"/>
               </a:rPr>
               <a:t>🏪200㎡</a:t>
             </a:r>
@@ -3792,7 +3792,7 @@
                 <a:solidFill>
                   <a:srgbClr val="FFFFFF"/>
                 </a:solidFill>
-                <a:latin typeface="WenQuanYi Micro Hei"/>
+                <a:latin typeface="Microsoft YaHei"/>
               </a:rPr>
               <a:t>🆕未开业新店</a:t>
             </a:r>
@@ -3837,7 +3837,7 @@
                 <a:solidFill>
                   <a:srgbClr val="9AACC2"/>
                 </a:solidFill>
-                <a:latin typeface="WenQuanYi Micro Hei"/>
+                <a:latin typeface="Microsoft YaHei"/>
               </a:rPr>
               <a:t>美团餐饮SaaS运营策划团队  |  2026年6月</a:t>
             </a:r>
@@ -3882,7 +3882,7 @@
                 <a:solidFill>
                   <a:srgbClr val="6E8098"/>
                 </a:solidFill>
-                <a:latin typeface="WenQuanYi Micro Hei"/>
+                <a:latin typeface="Microsoft YaHei"/>
               </a:rPr>
               <a:t>门店ID 1024066744378845</a:t>
             </a:r>
@@ -4085,7 +4085,7 @@
                 <a:solidFill>
                   <a:srgbClr val="B8CBE0"/>
                 </a:solidFill>
-                <a:latin typeface="WenQuanYi Micro Hei"/>
+                <a:latin typeface="Microsoft YaHei"/>
               </a:rPr>
               <a:t>OMNICHANNEL · 公私域联动</a:t>
             </a:r>
@@ -4130,7 +4130,7 @@
                 <a:solidFill>
                   <a:srgbClr val="FFFFFF"/>
                 </a:solidFill>
-                <a:latin typeface="WenQuanYi Micro Hei"/>
+                <a:latin typeface="Microsoft YaHei"/>
               </a:rPr>
               <a:t>从公域拉新到私域复购的一条闭环</a:t>
             </a:r>
@@ -4314,7 +4314,7 @@
                 <a:solidFill>
                   <a:srgbClr val="FFFFFF"/>
                 </a:solidFill>
-                <a:latin typeface="WenQuanYi Micro Hei"/>
+                <a:latin typeface="Microsoft YaHei"/>
               </a:rPr>
               <a:t>①</a:t>
             </a:r>
@@ -4359,7 +4359,7 @@
                 <a:solidFill>
                   <a:srgbClr val="FFFFFF"/>
                 </a:solidFill>
-                <a:latin typeface="WenQuanYi Micro Hei"/>
+                <a:latin typeface="Microsoft YaHei"/>
               </a:rPr>
               <a:t>公域引流</a:t>
             </a:r>
@@ -4404,7 +4404,7 @@
                 <a:solidFill>
                   <a:srgbClr val="1A73E8"/>
                 </a:solidFill>
-                <a:latin typeface="WenQuanYi Micro Hei"/>
+                <a:latin typeface="Microsoft YaHei"/>
               </a:rPr>
               <a:t>• </a:t>
             </a:r>
@@ -4413,7 +4413,7 @@
                 <a:solidFill>
                   <a:srgbClr val="222A33"/>
                 </a:solidFill>
-                <a:latin typeface="WenQuanYi Micro Hei"/>
+                <a:latin typeface="Microsoft YaHei"/>
               </a:rPr>
               <a:t>大众点评：商户页+预售团购</a:t>
             </a:r>
@@ -4458,7 +4458,7 @@
                 <a:solidFill>
                   <a:srgbClr val="1A73E8"/>
                 </a:solidFill>
-                <a:latin typeface="WenQuanYi Micro Hei"/>
+                <a:latin typeface="Microsoft YaHei"/>
               </a:rPr>
               <a:t>• </a:t>
             </a:r>
@@ -4467,7 +4467,7 @@
                 <a:solidFill>
                   <a:srgbClr val="222A33"/>
                 </a:solidFill>
-                <a:latin typeface="WenQuanYi Micro Hei"/>
+                <a:latin typeface="Microsoft YaHei"/>
               </a:rPr>
               <a:t>+90天新店推广通精准曝光</a:t>
             </a:r>
@@ -4512,7 +4512,7 @@
                 <a:solidFill>
                   <a:srgbClr val="1A73E8"/>
                 </a:solidFill>
-                <a:latin typeface="WenQuanYi Micro Hei"/>
+                <a:latin typeface="Microsoft YaHei"/>
               </a:rPr>
               <a:t>• </a:t>
             </a:r>
@@ -4521,7 +4521,7 @@
                 <a:solidFill>
                   <a:srgbClr val="222A33"/>
                 </a:solidFill>
-                <a:latin typeface="WenQuanYi Micro Hei"/>
+                <a:latin typeface="Microsoft YaHei"/>
               </a:rPr>
               <a:t>小红书：滨江夜宵打卡探店</a:t>
             </a:r>
@@ -4566,7 +4566,7 @@
                 <a:solidFill>
                   <a:srgbClr val="1A73E8"/>
                 </a:solidFill>
-                <a:latin typeface="WenQuanYi Micro Hei"/>
+                <a:latin typeface="Microsoft YaHei"/>
               </a:rPr>
               <a:t>• </a:t>
             </a:r>
@@ -4575,7 +4575,7 @@
                 <a:solidFill>
                   <a:srgbClr val="222A33"/>
                 </a:solidFill>
-                <a:latin typeface="WenQuanYi Micro Hei"/>
+                <a:latin typeface="Microsoft YaHei"/>
               </a:rPr>
               <a:t>抖音：现烤烟火气短视频</a:t>
             </a:r>
@@ -4620,7 +4620,7 @@
                 <a:solidFill>
                   <a:srgbClr val="FF6D00"/>
                 </a:solidFill>
-                <a:latin typeface="WenQuanYi Micro Hei"/>
+                <a:latin typeface="Microsoft YaHei"/>
               </a:rPr>
               <a:t>▶</a:t>
             </a:r>
@@ -4804,7 +4804,7 @@
                 <a:solidFill>
                   <a:srgbClr val="FFFFFF"/>
                 </a:solidFill>
-                <a:latin typeface="WenQuanYi Micro Hei"/>
+                <a:latin typeface="Microsoft YaHei"/>
               </a:rPr>
               <a:t>②</a:t>
             </a:r>
@@ -4849,7 +4849,7 @@
                 <a:solidFill>
                   <a:srgbClr val="FFFFFF"/>
                 </a:solidFill>
-                <a:latin typeface="WenQuanYi Micro Hei"/>
+                <a:latin typeface="Microsoft YaHei"/>
               </a:rPr>
               <a:t>到店转化</a:t>
             </a:r>
@@ -4894,7 +4894,7 @@
                 <a:solidFill>
                   <a:srgbClr val="FF6D00"/>
                 </a:solidFill>
-                <a:latin typeface="WenQuanYi Micro Hei"/>
+                <a:latin typeface="Microsoft YaHei"/>
               </a:rPr>
               <a:t>• </a:t>
             </a:r>
@@ -4903,7 +4903,7 @@
                 <a:solidFill>
                   <a:srgbClr val="222A33"/>
                 </a:solidFill>
-                <a:latin typeface="WenQuanYi Micro Hei"/>
+                <a:latin typeface="Microsoft YaHei"/>
               </a:rPr>
               <a:t>扫码点餐=自动注册会员</a:t>
             </a:r>
@@ -4948,7 +4948,7 @@
                 <a:solidFill>
                   <a:srgbClr val="FF6D00"/>
                 </a:solidFill>
-                <a:latin typeface="WenQuanYi Micro Hei"/>
+                <a:latin typeface="Microsoft YaHei"/>
               </a:rPr>
               <a:t>• </a:t>
             </a:r>
@@ -4957,7 +4957,7 @@
                 <a:solidFill>
                   <a:srgbClr val="222A33"/>
                 </a:solidFill>
-                <a:latin typeface="WenQuanYi Micro Hei"/>
+                <a:latin typeface="Microsoft YaHei"/>
               </a:rPr>
               <a:t>结账弹储值推荐(每桌必问)</a:t>
             </a:r>
@@ -5002,7 +5002,7 @@
                 <a:solidFill>
                   <a:srgbClr val="FF6D00"/>
                 </a:solidFill>
-                <a:latin typeface="WenQuanYi Micro Hei"/>
+                <a:latin typeface="Microsoft YaHei"/>
               </a:rPr>
               <a:t>• </a:t>
             </a:r>
@@ -5011,7 +5011,7 @@
                 <a:solidFill>
                   <a:srgbClr val="222A33"/>
                 </a:solidFill>
-                <a:latin typeface="WenQuanYi Micro Hei"/>
+                <a:latin typeface="Microsoft YaHei"/>
               </a:rPr>
               <a:t>峰值体验:小龙虾上桌仪式感</a:t>
             </a:r>
@@ -5056,7 +5056,7 @@
                 <a:solidFill>
                   <a:srgbClr val="FF6D00"/>
                 </a:solidFill>
-                <a:latin typeface="WenQuanYi Micro Hei"/>
+                <a:latin typeface="Microsoft YaHei"/>
               </a:rPr>
               <a:t>• </a:t>
             </a:r>
@@ -5065,7 +5065,7 @@
                 <a:solidFill>
                   <a:srgbClr val="222A33"/>
                 </a:solidFill>
-                <a:latin typeface="WenQuanYi Micro Hei"/>
+                <a:latin typeface="Microsoft YaHei"/>
               </a:rPr>
               <a:t>终值:结账弹好评页+离店券</a:t>
             </a:r>
@@ -5110,7 +5110,7 @@
                 <a:solidFill>
                   <a:srgbClr val="FF6D00"/>
                 </a:solidFill>
-                <a:latin typeface="WenQuanYi Micro Hei"/>
+                <a:latin typeface="Microsoft YaHei"/>
               </a:rPr>
               <a:t>▶</a:t>
             </a:r>
@@ -5294,7 +5294,7 @@
                 <a:solidFill>
                   <a:srgbClr val="FFFFFF"/>
                 </a:solidFill>
-                <a:latin typeface="WenQuanYi Micro Hei"/>
+                <a:latin typeface="Microsoft YaHei"/>
               </a:rPr>
               <a:t>③</a:t>
             </a:r>
@@ -5339,7 +5339,7 @@
                 <a:solidFill>
                   <a:srgbClr val="FFFFFF"/>
                 </a:solidFill>
-                <a:latin typeface="WenQuanYi Micro Hei"/>
+                <a:latin typeface="Microsoft YaHei"/>
               </a:rPr>
               <a:t>私域沉淀</a:t>
             </a:r>
@@ -5384,7 +5384,7 @@
                 <a:solidFill>
                   <a:srgbClr val="1EA06A"/>
                 </a:solidFill>
-                <a:latin typeface="WenQuanYi Micro Hei"/>
+                <a:latin typeface="Microsoft YaHei"/>
               </a:rPr>
               <a:t>• </a:t>
             </a:r>
@@ -5393,7 +5393,7 @@
                 <a:solidFill>
                   <a:srgbClr val="222A33"/>
                 </a:solidFill>
-                <a:latin typeface="WenQuanYi Micro Hei"/>
+                <a:latin typeface="Microsoft YaHei"/>
               </a:rPr>
               <a:t>企微深夜食堂群,群内9折</a:t>
             </a:r>
@@ -5438,7 +5438,7 @@
                 <a:solidFill>
                   <a:srgbClr val="1EA06A"/>
                 </a:solidFill>
-                <a:latin typeface="WenQuanYi Micro Hei"/>
+                <a:latin typeface="Microsoft YaHei"/>
               </a:rPr>
               <a:t>• </a:t>
             </a:r>
@@ -5447,7 +5447,7 @@
                 <a:solidFill>
                   <a:srgbClr val="222A33"/>
                 </a:solidFill>
-                <a:latin typeface="WenQuanYi Micro Hei"/>
+                <a:latin typeface="Microsoft YaHei"/>
               </a:rPr>
               <a:t>会员标签:新客/高频/沉睡</a:t>
             </a:r>
@@ -5492,7 +5492,7 @@
                 <a:solidFill>
                   <a:srgbClr val="1EA06A"/>
                 </a:solidFill>
-                <a:latin typeface="WenQuanYi Micro Hei"/>
+                <a:latin typeface="Microsoft YaHei"/>
               </a:rPr>
               <a:t>• </a:t>
             </a:r>
@@ -5501,7 +5501,7 @@
                 <a:solidFill>
                   <a:srgbClr val="222A33"/>
                 </a:solidFill>
-                <a:latin typeface="WenQuanYi Micro Hei"/>
+                <a:latin typeface="Microsoft YaHei"/>
               </a:rPr>
               <a:t>储值锁客,等级养客</a:t>
             </a:r>
@@ -5546,7 +5546,7 @@
                 <a:solidFill>
                   <a:srgbClr val="1EA06A"/>
                 </a:solidFill>
-                <a:latin typeface="WenQuanYi Micro Hei"/>
+                <a:latin typeface="Microsoft YaHei"/>
               </a:rPr>
               <a:t>• </a:t>
             </a:r>
@@ -5555,7 +5555,7 @@
                 <a:solidFill>
                   <a:srgbClr val="222A33"/>
                 </a:solidFill>
-                <a:latin typeface="WenQuanYi Micro Hei"/>
+                <a:latin typeface="Microsoft YaHei"/>
               </a:rPr>
               <a:t>生日/节日自动推券</a:t>
             </a:r>
@@ -5600,7 +5600,7 @@
                 <a:solidFill>
                   <a:srgbClr val="FF6D00"/>
                 </a:solidFill>
-                <a:latin typeface="WenQuanYi Micro Hei"/>
+                <a:latin typeface="Microsoft YaHei"/>
               </a:rPr>
               <a:t>▶</a:t>
             </a:r>
@@ -5784,7 +5784,7 @@
                 <a:solidFill>
                   <a:srgbClr val="FFFFFF"/>
                 </a:solidFill>
-                <a:latin typeface="WenQuanYi Micro Hei"/>
+                <a:latin typeface="Microsoft YaHei"/>
               </a:rPr>
               <a:t>④</a:t>
             </a:r>
@@ -5829,7 +5829,7 @@
                 <a:solidFill>
                   <a:srgbClr val="FFFFFF"/>
                 </a:solidFill>
-                <a:latin typeface="WenQuanYi Micro Hei"/>
+                <a:latin typeface="Microsoft YaHei"/>
               </a:rPr>
               <a:t>复购唤醒</a:t>
             </a:r>
@@ -5874,7 +5874,7 @@
                 <a:solidFill>
                   <a:srgbClr val="122A4A"/>
                 </a:solidFill>
-                <a:latin typeface="WenQuanYi Micro Hei"/>
+                <a:latin typeface="Microsoft YaHei"/>
               </a:rPr>
               <a:t>• </a:t>
             </a:r>
@@ -5883,7 +5883,7 @@
                 <a:solidFill>
                   <a:srgbClr val="222A33"/>
                 </a:solidFill>
-                <a:latin typeface="WenQuanYi Micro Hei"/>
+                <a:latin typeface="Microsoft YaHei"/>
               </a:rPr>
               <a:t>30天未到店→自动推券</a:t>
             </a:r>
@@ -5928,7 +5928,7 @@
                 <a:solidFill>
                   <a:srgbClr val="122A4A"/>
                 </a:solidFill>
-                <a:latin typeface="WenQuanYi Micro Hei"/>
+                <a:latin typeface="Microsoft YaHei"/>
               </a:rPr>
               <a:t>• </a:t>
             </a:r>
@@ -5937,7 +5937,7 @@
                 <a:solidFill>
                   <a:srgbClr val="222A33"/>
                 </a:solidFill>
-                <a:latin typeface="WenQuanYi Micro Hei"/>
+                <a:latin typeface="Microsoft YaHei"/>
               </a:rPr>
               <a:t>小龙虾上新→群内首发</a:t>
             </a:r>
@@ -5982,7 +5982,7 @@
                 <a:solidFill>
                   <a:srgbClr val="122A4A"/>
                 </a:solidFill>
-                <a:latin typeface="WenQuanYi Micro Hei"/>
+                <a:latin typeface="Microsoft YaHei"/>
               </a:rPr>
               <a:t>• </a:t>
             </a:r>
@@ -5991,7 +5991,7 @@
                 <a:solidFill>
                   <a:srgbClr val="222A33"/>
                 </a:solidFill>
-                <a:latin typeface="WenQuanYi Micro Hei"/>
+                <a:latin typeface="Microsoft YaHei"/>
               </a:rPr>
               <a:t>会员专属夜宵套餐</a:t>
             </a:r>
@@ -6036,7 +6036,7 @@
                 <a:solidFill>
                   <a:srgbClr val="122A4A"/>
                 </a:solidFill>
-                <a:latin typeface="WenQuanYi Micro Hei"/>
+                <a:latin typeface="Microsoft YaHei"/>
               </a:rPr>
               <a:t>• </a:t>
             </a:r>
@@ -6045,7 +6045,7 @@
                 <a:solidFill>
                   <a:srgbClr val="222A33"/>
                 </a:solidFill>
-                <a:latin typeface="WenQuanYi Micro Hei"/>
+                <a:latin typeface="Microsoft YaHei"/>
               </a:rPr>
               <a:t>数据复盘→优化爆款排班</a:t>
             </a:r>
@@ -6090,7 +6090,7 @@
                 <a:solidFill>
                   <a:srgbClr val="122A4A"/>
                 </a:solidFill>
-                <a:latin typeface="WenQuanYi Micro Hei"/>
+                <a:latin typeface="Microsoft YaHei"/>
               </a:rPr>
               <a:t>🔁 闭环本质：</a:t>
             </a:r>
@@ -6099,7 +6099,7 @@
                 <a:solidFill>
                   <a:srgbClr val="6B7280"/>
                 </a:solidFill>
-                <a:latin typeface="WenQuanYi Micro Hei"/>
+                <a:latin typeface="Microsoft YaHei"/>
               </a:rPr>
               <a:t>公域花钱买的每一个新客,都通过扫码入会沉淀进私域,后续复购靠系统自动唤醒——广告费只花一次,客人反复来。</a:t>
             </a:r>
@@ -6144,7 +6144,7 @@
                 <a:solidFill>
                   <a:srgbClr val="AAB2BC"/>
                 </a:solidFill>
-                <a:latin typeface="WenQuanYi Micro Hei"/>
+                <a:latin typeface="Microsoft YaHei"/>
               </a:rPr>
               <a:t>新豪仔小龙虾烧烤融合菜 · 数字化经营解决方案</a:t>
             </a:r>
@@ -6189,7 +6189,7 @@
                 <a:solidFill>
                   <a:srgbClr val="6B7280"/>
                 </a:solidFill>
-                <a:latin typeface="WenQuanYi Micro Hei"/>
+                <a:latin typeface="Microsoft YaHei"/>
               </a:rPr>
               <a:t>10</a:t>
             </a:r>
@@ -6392,7 +6392,7 @@
                 <a:solidFill>
                   <a:srgbClr val="B8CBE0"/>
                 </a:solidFill>
-                <a:latin typeface="WenQuanYi Micro Hei"/>
+                <a:latin typeface="Microsoft YaHei"/>
               </a:rPr>
               <a:t>CALENDAR · 营销节奏</a:t>
             </a:r>
@@ -6437,7 +6437,7 @@
                 <a:solidFill>
                   <a:srgbClr val="FFFFFF"/>
                 </a:solidFill>
-                <a:latin typeface="WenQuanYi Micro Hei"/>
+                <a:latin typeface="Microsoft YaHei"/>
               </a:rPr>
               <a:t>开业90天逐周作战日历</a:t>
             </a:r>
@@ -6526,7 +6526,7 @@
                 <a:solidFill>
                   <a:srgbClr val="FFFFFF"/>
                 </a:solidFill>
-                <a:latin typeface="WenQuanYi Micro Hei"/>
+                <a:latin typeface="Microsoft YaHei"/>
               </a:rPr>
               <a:t>蓄水期 · 开业前4周</a:t>
             </a:r>
@@ -6615,7 +6615,7 @@
                 <a:solidFill>
                   <a:srgbClr val="FFFFFF"/>
                 </a:solidFill>
-                <a:latin typeface="WenQuanYi Micro Hei"/>
+                <a:latin typeface="Microsoft YaHei"/>
               </a:rPr>
               <a:t>前4周</a:t>
             </a:r>
@@ -6704,7 +6704,7 @@
                 <a:solidFill>
                   <a:srgbClr val="222A33"/>
                 </a:solidFill>
-                <a:latin typeface="WenQuanYi Micro Hei"/>
+                <a:latin typeface="Microsoft YaHei"/>
               </a:rPr>
               <a:t>点评商户页上线+20张图,企微社群搭建,小红书装修探店3篇</a:t>
             </a:r>
@@ -6793,7 +6793,7 @@
                 <a:solidFill>
                   <a:srgbClr val="FFFFFF"/>
                 </a:solidFill>
-                <a:latin typeface="WenQuanYi Micro Hei"/>
+                <a:latin typeface="Microsoft YaHei"/>
               </a:rPr>
               <a:t>前2周</a:t>
             </a:r>
@@ -6882,7 +6882,7 @@
                 <a:solidFill>
                   <a:srgbClr val="222A33"/>
                 </a:solidFill>
-                <a:latin typeface="WenQuanYi Micro Hei"/>
+                <a:latin typeface="Microsoft YaHei"/>
               </a:rPr>
               <a:t>上线预售团购(小龙虾套餐),试营业7折磨合出餐,KOC控场攒首评</a:t>
             </a:r>
@@ -6971,7 +6971,7 @@
                 <a:solidFill>
                   <a:srgbClr val="FFFFFF"/>
                 </a:solidFill>
-                <a:latin typeface="WenQuanYi Micro Hei"/>
+                <a:latin typeface="Microsoft YaHei"/>
               </a:rPr>
               <a:t>前3天</a:t>
             </a:r>
@@ -7060,7 +7060,7 @@
                 <a:solidFill>
                   <a:srgbClr val="222A33"/>
                 </a:solidFill>
-                <a:latin typeface="WenQuanYi Micro Hei"/>
+                <a:latin typeface="Microsoft YaHei"/>
               </a:rPr>
               <a:t>点评免费试上线,达人探店预约,食材1.5倍备货,员工话术演练</a:t>
             </a:r>
@@ -7149,7 +7149,7 @@
                 <a:solidFill>
                   <a:srgbClr val="FFFFFF"/>
                 </a:solidFill>
-                <a:latin typeface="WenQuanYi Micro Hei"/>
+                <a:latin typeface="Microsoft YaHei"/>
               </a:rPr>
               <a:t>引爆期 · 开业1-2周</a:t>
             </a:r>
@@ -7238,7 +7238,7 @@
                 <a:solidFill>
                   <a:srgbClr val="FFFFFF"/>
                 </a:solidFill>
-                <a:latin typeface="WenQuanYi Micro Hei"/>
+                <a:latin typeface="Microsoft YaHei"/>
               </a:rPr>
               <a:t>第1周</a:t>
             </a:r>
@@ -7327,7 +7327,7 @@
                 <a:solidFill>
                   <a:srgbClr val="222A33"/>
                 </a:solidFill>
-                <a:latin typeface="WenQuanYi Micro Hei"/>
+                <a:latin typeface="Microsoft YaHei"/>
               </a:rPr>
               <a:t>开业三天啤酒买一送一+控流量保出餐,引导好评送饮品,冲50条优质评价</a:t>
             </a:r>
@@ -7416,7 +7416,7 @@
                 <a:solidFill>
                   <a:srgbClr val="FFFFFF"/>
                 </a:solidFill>
-                <a:latin typeface="WenQuanYi Micro Hei"/>
+                <a:latin typeface="Microsoft YaHei"/>
               </a:rPr>
               <a:t>第2周</a:t>
             </a:r>
@@ -7505,7 +7505,7 @@
                 <a:solidFill>
                   <a:srgbClr val="222A33"/>
                 </a:solidFill>
-                <a:latin typeface="WenQuanYi Micro Hei"/>
+                <a:latin typeface="Microsoft YaHei"/>
               </a:rPr>
               <a:t>折扣回调至8.8折,美团外卖上线抢7天扶持,抖音达人探店发布</a:t>
             </a:r>
@@ -7594,7 +7594,7 @@
                 <a:solidFill>
                   <a:srgbClr val="FFFFFF"/>
                 </a:solidFill>
-                <a:latin typeface="WenQuanYi Micro Hei"/>
+                <a:latin typeface="Microsoft YaHei"/>
               </a:rPr>
               <a:t>沉淀期 · 开业3-12周</a:t>
             </a:r>
@@ -7683,7 +7683,7 @@
                 <a:solidFill>
                   <a:srgbClr val="FFFFFF"/>
                 </a:solidFill>
-                <a:latin typeface="WenQuanYi Micro Hei"/>
+                <a:latin typeface="Microsoft YaHei"/>
               </a:rPr>
               <a:t>第3-4周</a:t>
             </a:r>
@@ -7772,7 +7772,7 @@
                 <a:solidFill>
                   <a:srgbClr val="222A33"/>
                 </a:solidFill>
-                <a:latin typeface="WenQuanYi Micro Hei"/>
+                <a:latin typeface="Microsoft YaHei"/>
               </a:rPr>
               <a:t>推储值(充300送50)+会员复购券,点评冲4.5★,企微群日常运营</a:t>
             </a:r>
@@ -7861,7 +7861,7 @@
                 <a:solidFill>
                   <a:srgbClr val="FFFFFF"/>
                 </a:solidFill>
-                <a:latin typeface="WenQuanYi Micro Hei"/>
+                <a:latin typeface="Microsoft YaHei"/>
               </a:rPr>
               <a:t>第5-12周</a:t>
             </a:r>
@@ -7950,7 +7950,7 @@
                 <a:solidFill>
                   <a:srgbClr val="222A33"/>
                 </a:solidFill>
-                <a:latin typeface="WenQuanYi Micro Hei"/>
+                <a:latin typeface="Microsoft YaHei"/>
               </a:rPr>
               <a:t>小龙虾旺季主推「夏夜限定」,冲点评热门榜,沉睡会员唤醒,数据复盘调爆款</a:t>
             </a:r>
@@ -7995,7 +7995,7 @@
                 <a:solidFill>
                   <a:srgbClr val="AAB2BC"/>
                 </a:solidFill>
-                <a:latin typeface="WenQuanYi Micro Hei"/>
+                <a:latin typeface="Microsoft YaHei"/>
               </a:rPr>
               <a:t>新豪仔小龙虾烧烤融合菜 · 数字化经营解决方案</a:t>
             </a:r>
@@ -8040,7 +8040,7 @@
                 <a:solidFill>
                   <a:srgbClr val="6B7280"/>
                 </a:solidFill>
-                <a:latin typeface="WenQuanYi Micro Hei"/>
+                <a:latin typeface="Microsoft YaHei"/>
               </a:rPr>
               <a:t>11</a:t>
             </a:r>
@@ -8243,7 +8243,7 @@
                 <a:solidFill>
                   <a:srgbClr val="B8CBE0"/>
                 </a:solidFill>
-                <a:latin typeface="WenQuanYi Micro Hei"/>
+                <a:latin typeface="Microsoft YaHei"/>
               </a:rPr>
               <a:t>OKR · 量化目标</a:t>
             </a:r>
@@ -8288,7 +8288,7 @@
                 <a:solidFill>
                   <a:srgbClr val="FFFFFF"/>
                 </a:solidFill>
-                <a:latin typeface="WenQuanYi Micro Hei"/>
+                <a:latin typeface="Microsoft YaHei"/>
               </a:rPr>
               <a:t>开业90天可量化作战目标</a:t>
             </a:r>
@@ -8333,7 +8333,7 @@
                 <a:solidFill>
                   <a:srgbClr val="6B7280"/>
                 </a:solidFill>
-                <a:latin typeface="WenQuanYi Micro Hei"/>
+                <a:latin typeface="Microsoft YaHei"/>
               </a:rPr>
               <a:t>目标拆到月,每月有抓手、有数字,月底能对账。</a:t>
             </a:r>
@@ -8473,7 +8473,7 @@
                 <a:solidFill>
                   <a:srgbClr val="FF6D00"/>
                 </a:solidFill>
-                <a:latin typeface="WenQuanYi Micro Hei"/>
+                <a:latin typeface="Microsoft YaHei"/>
               </a:rPr>
               <a:t>📈</a:t>
             </a:r>
@@ -8518,7 +8518,7 @@
                 <a:solidFill>
                   <a:srgbClr val="6B7280"/>
                 </a:solidFill>
-                <a:latin typeface="WenQuanYi Micro Hei"/>
+                <a:latin typeface="Microsoft YaHei"/>
               </a:rPr>
               <a:t>月营业额</a:t>
             </a:r>
@@ -8563,7 +8563,7 @@
                 <a:solidFill>
                   <a:srgbClr val="FF6D00"/>
                 </a:solidFill>
-                <a:latin typeface="WenQuanYi Micro Hei"/>
+                <a:latin typeface="Microsoft YaHei"/>
               </a:rPr>
               <a:t>¥24万</a:t>
             </a:r>
@@ -8608,7 +8608,7 @@
                 <a:solidFill>
                   <a:srgbClr val="222A33"/>
                 </a:solidFill>
-                <a:latin typeface="WenQuanYi Micro Hei"/>
+                <a:latin typeface="Microsoft YaHei"/>
               </a:rPr>
               <a:t>稳定期(第3月)目标,日均¥8K×30</a:t>
             </a:r>
@@ -8748,7 +8748,7 @@
                 <a:solidFill>
                   <a:srgbClr val="1A73E8"/>
                 </a:solidFill>
-                <a:latin typeface="WenQuanYi Micro Hei"/>
+                <a:latin typeface="Microsoft YaHei"/>
               </a:rPr>
               <a:t>⭐</a:t>
             </a:r>
@@ -8793,7 +8793,7 @@
                 <a:solidFill>
                   <a:srgbClr val="6B7280"/>
                 </a:solidFill>
-                <a:latin typeface="WenQuanYi Micro Hei"/>
+                <a:latin typeface="Microsoft YaHei"/>
               </a:rPr>
               <a:t>大众点评</a:t>
             </a:r>
@@ -8838,7 +8838,7 @@
                 <a:solidFill>
                   <a:srgbClr val="1A73E8"/>
                 </a:solidFill>
-                <a:latin typeface="WenQuanYi Micro Hei"/>
+                <a:latin typeface="Microsoft YaHei"/>
               </a:rPr>
               <a:t>4.5★ + 200评价</a:t>
             </a:r>
@@ -8883,7 +8883,7 @@
                 <a:solidFill>
                   <a:srgbClr val="222A33"/>
                 </a:solidFill>
-                <a:latin typeface="WenQuanYi Micro Hei"/>
+                <a:latin typeface="Microsoft YaHei"/>
               </a:rPr>
               <a:t>新店90天攒真实评价,冲热门榜</a:t>
             </a:r>
@@ -9023,7 +9023,7 @@
                 <a:solidFill>
                   <a:srgbClr val="1EA06A"/>
                 </a:solidFill>
-                <a:latin typeface="WenQuanYi Micro Hei"/>
+                <a:latin typeface="Microsoft YaHei"/>
               </a:rPr>
               <a:t>👥</a:t>
             </a:r>
@@ -9068,7 +9068,7 @@
                 <a:solidFill>
                   <a:srgbClr val="6B7280"/>
                 </a:solidFill>
-                <a:latin typeface="WenQuanYi Micro Hei"/>
+                <a:latin typeface="Microsoft YaHei"/>
               </a:rPr>
               <a:t>会员总数</a:t>
             </a:r>
@@ -9113,7 +9113,7 @@
                 <a:solidFill>
                   <a:srgbClr val="1EA06A"/>
                 </a:solidFill>
-                <a:latin typeface="WenQuanYi Micro Hei"/>
+                <a:latin typeface="Microsoft YaHei"/>
               </a:rPr>
               <a:t>800+人</a:t>
             </a:r>
@@ -9158,7 +9158,7 @@
                 <a:solidFill>
                   <a:srgbClr val="222A33"/>
                 </a:solidFill>
-                <a:latin typeface="WenQuanYi Micro Hei"/>
+                <a:latin typeface="Microsoft YaHei"/>
               </a:rPr>
               <a:t>扫码点餐自动入会沉淀</a:t>
             </a:r>
@@ -9298,7 +9298,7 @@
                 <a:solidFill>
                   <a:srgbClr val="E8A817"/>
                 </a:solidFill>
-                <a:latin typeface="WenQuanYi Micro Hei"/>
+                <a:latin typeface="Microsoft YaHei"/>
               </a:rPr>
               <a:t>💳</a:t>
             </a:r>
@@ -9343,7 +9343,7 @@
                 <a:solidFill>
                   <a:srgbClr val="6B7280"/>
                 </a:solidFill>
-                <a:latin typeface="WenQuanYi Micro Hei"/>
+                <a:latin typeface="Microsoft YaHei"/>
               </a:rPr>
               <a:t>储值入账</a:t>
             </a:r>
@@ -9388,7 +9388,7 @@
                 <a:solidFill>
                   <a:srgbClr val="E8A817"/>
                 </a:solidFill>
-                <a:latin typeface="WenQuanYi Micro Hei"/>
+                <a:latin typeface="Microsoft YaHei"/>
               </a:rPr>
               <a:t>¥4万/月</a:t>
             </a:r>
@@ -9433,7 +9433,7 @@
                 <a:solidFill>
                   <a:srgbClr val="222A33"/>
                 </a:solidFill>
-                <a:latin typeface="WenQuanYi Micro Hei"/>
+                <a:latin typeface="Microsoft YaHei"/>
               </a:rPr>
               <a:t>首月15-20%营业额转储值</a:t>
             </a:r>
@@ -9573,7 +9573,7 @@
                 <a:solidFill>
                   <a:srgbClr val="E53A3A"/>
                 </a:solidFill>
-                <a:latin typeface="WenQuanYi Micro Hei"/>
+                <a:latin typeface="Microsoft YaHei"/>
               </a:rPr>
               <a:t>🛵</a:t>
             </a:r>
@@ -9618,7 +9618,7 @@
                 <a:solidFill>
                   <a:srgbClr val="6B7280"/>
                 </a:solidFill>
-                <a:latin typeface="WenQuanYi Micro Hei"/>
+                <a:latin typeface="Microsoft YaHei"/>
               </a:rPr>
               <a:t>外卖日单</a:t>
             </a:r>
@@ -9663,7 +9663,7 @@
                 <a:solidFill>
                   <a:srgbClr val="E53A3A"/>
                 </a:solidFill>
-                <a:latin typeface="WenQuanYi Micro Hei"/>
+                <a:latin typeface="Microsoft YaHei"/>
               </a:rPr>
               <a:t>60单</a:t>
             </a:r>
@@ -9708,7 +9708,7 @@
                 <a:solidFill>
                   <a:srgbClr val="222A33"/>
                 </a:solidFill>
-                <a:latin typeface="WenQuanYi Micro Hei"/>
+                <a:latin typeface="Microsoft YaHei"/>
               </a:rPr>
               <a:t>开业第2周上线抢7天扶持</a:t>
             </a:r>
@@ -9848,7 +9848,7 @@
                 <a:solidFill>
                   <a:srgbClr val="122A4A"/>
                 </a:solidFill>
-                <a:latin typeface="WenQuanYi Micro Hei"/>
+                <a:latin typeface="Microsoft YaHei"/>
               </a:rPr>
               <a:t>🔁</a:t>
             </a:r>
@@ -9893,7 +9893,7 @@
                 <a:solidFill>
                   <a:srgbClr val="6B7280"/>
                 </a:solidFill>
-                <a:latin typeface="WenQuanYi Micro Hei"/>
+                <a:latin typeface="Microsoft YaHei"/>
               </a:rPr>
               <a:t>复购率</a:t>
             </a:r>
@@ -9938,7 +9938,7 @@
                 <a:solidFill>
                   <a:srgbClr val="122A4A"/>
                 </a:solidFill>
-                <a:latin typeface="WenQuanYi Micro Hei"/>
+                <a:latin typeface="Microsoft YaHei"/>
               </a:rPr>
               <a:t>35%</a:t>
             </a:r>
@@ -9983,7 +9983,7 @@
                 <a:solidFill>
                   <a:srgbClr val="222A33"/>
                 </a:solidFill>
-                <a:latin typeface="WenQuanYi Micro Hei"/>
+                <a:latin typeface="Microsoft YaHei"/>
               </a:rPr>
               <a:t>会员唤醒+储值锁客拉动</a:t>
             </a:r>
@@ -10028,7 +10028,7 @@
                 <a:solidFill>
                   <a:srgbClr val="AAB2BC"/>
                 </a:solidFill>
-                <a:latin typeface="WenQuanYi Micro Hei"/>
+                <a:latin typeface="Microsoft YaHei"/>
               </a:rPr>
               <a:t>新豪仔小龙虾烧烤融合菜 · 数字化经营解决方案</a:t>
             </a:r>
@@ -10073,7 +10073,7 @@
                 <a:solidFill>
                   <a:srgbClr val="6B7280"/>
                 </a:solidFill>
-                <a:latin typeface="WenQuanYi Micro Hei"/>
+                <a:latin typeface="Microsoft YaHei"/>
               </a:rPr>
               <a:t>12</a:t>
             </a:r>
@@ -10276,7 +10276,7 @@
                 <a:solidFill>
                   <a:srgbClr val="B8CBE0"/>
                 </a:solidFill>
-                <a:latin typeface="WenQuanYi Micro Hei"/>
+                <a:latin typeface="Microsoft YaHei"/>
               </a:rPr>
               <a:t>ROI · 投资回报</a:t>
             </a:r>
@@ -10321,7 +10321,7 @@
                 <a:solidFill>
                   <a:srgbClr val="FFFFFF"/>
                 </a:solidFill>
-                <a:latin typeface="WenQuanYi Micro Hei"/>
+                <a:latin typeface="Microsoft YaHei"/>
               </a:rPr>
               <a:t>算清账：投入多少，多久回本</a:t>
             </a:r>
@@ -10417,7 +10417,7 @@
                 <a:solidFill>
                   <a:srgbClr val="122A4A"/>
                 </a:solidFill>
-                <a:latin typeface="WenQuanYi Micro Hei"/>
+                <a:latin typeface="Microsoft YaHei"/>
               </a:rPr>
               <a:t>💼 投入明细(参考)</a:t>
             </a:r>
@@ -10506,7 +10506,7 @@
                 <a:solidFill>
                   <a:srgbClr val="222A33"/>
                 </a:solidFill>
-                <a:latin typeface="WenQuanYi Micro Hei"/>
+                <a:latin typeface="Microsoft YaHei"/>
               </a:rPr>
               <a:t>软件·餐饮管理高级营销版</a:t>
             </a:r>
@@ -10528,7 +10528,7 @@
                 <a:solidFill>
                   <a:srgbClr val="6B7280"/>
                 </a:solidFill>
-                <a:latin typeface="WenQuanYi Micro Hei"/>
+                <a:latin typeface="Microsoft YaHei"/>
               </a:rPr>
               <a:t>含收银+扫码点餐+会员旗舰+小程序</a:t>
             </a:r>
@@ -10573,7 +10573,7 @@
                 <a:solidFill>
                   <a:srgbClr val="FF6D00"/>
                 </a:solidFill>
-                <a:latin typeface="WenQuanYi Micro Hei"/>
+                <a:latin typeface="Microsoft YaHei"/>
               </a:rPr>
               <a:t>¥6,288/年</a:t>
             </a:r>
@@ -10662,7 +10662,7 @@
                 <a:solidFill>
                   <a:srgbClr val="222A33"/>
                 </a:solidFill>
-                <a:latin typeface="WenQuanYi Micro Hei"/>
+                <a:latin typeface="Microsoft YaHei"/>
               </a:rPr>
               <a:t>硬件·收银一体机+扫码盒+打印机</a:t>
             </a:r>
@@ -10684,7 +10684,7 @@
                 <a:solidFill>
                   <a:srgbClr val="6B7280"/>
                 </a:solidFill>
-                <a:latin typeface="WenQuanYi Micro Hei"/>
+                <a:latin typeface="Microsoft YaHei"/>
               </a:rPr>
               <a:t>一次性,按门店配置</a:t>
             </a:r>
@@ -10729,7 +10729,7 @@
                 <a:solidFill>
                   <a:srgbClr val="FF6D00"/>
                 </a:solidFill>
-                <a:latin typeface="WenQuanYi Micro Hei"/>
+                <a:latin typeface="Microsoft YaHei"/>
               </a:rPr>
               <a:t>约¥3,000</a:t>
             </a:r>
@@ -10818,7 +10818,7 @@
                 <a:solidFill>
                   <a:srgbClr val="222A33"/>
                 </a:solidFill>
-                <a:latin typeface="WenQuanYi Micro Hei"/>
+                <a:latin typeface="Microsoft YaHei"/>
               </a:rPr>
               <a:t>评价专家(口碑必备)</a:t>
             </a:r>
@@ -10840,7 +10840,7 @@
                 <a:solidFill>
                   <a:srgbClr val="6B7280"/>
                 </a:solidFill>
-                <a:latin typeface="WenQuanYi Micro Hei"/>
+                <a:latin typeface="Microsoft YaHei"/>
               </a:rPr>
               <a:t>新店90天攒评价关键工具</a:t>
             </a:r>
@@ -10885,7 +10885,7 @@
                 <a:solidFill>
                   <a:srgbClr val="FF6D00"/>
                 </a:solidFill>
-                <a:latin typeface="WenQuanYi Micro Hei"/>
+                <a:latin typeface="Microsoft YaHei"/>
               </a:rPr>
               <a:t>按标价</a:t>
             </a:r>
@@ -10974,7 +10974,7 @@
                 <a:solidFill>
                   <a:srgbClr val="222A33"/>
                 </a:solidFill>
-                <a:latin typeface="WenQuanYi Micro Hei"/>
+                <a:latin typeface="Microsoft YaHei"/>
               </a:rPr>
               <a:t>开业营销预算</a:t>
             </a:r>
@@ -10996,7 +10996,7 @@
                 <a:solidFill>
                   <a:srgbClr val="6B7280"/>
                 </a:solidFill>
-                <a:latin typeface="WenQuanYi Micro Hei"/>
+                <a:latin typeface="Microsoft YaHei"/>
               </a:rPr>
               <a:t>点评推广+达人+物料+折扣让利</a:t>
             </a:r>
@@ -11041,7 +11041,7 @@
                 <a:solidFill>
                   <a:srgbClr val="FF6D00"/>
                 </a:solidFill>
-                <a:latin typeface="WenQuanYi Micro Hei"/>
+                <a:latin typeface="Microsoft YaHei"/>
               </a:rPr>
               <a:t>¥1.1–1.9万</a:t>
             </a:r>
@@ -11086,7 +11086,7 @@
                 <a:solidFill>
                   <a:srgbClr val="6B7280"/>
                 </a:solidFill>
-                <a:latin typeface="WenQuanYi Micro Hei"/>
+                <a:latin typeface="Microsoft YaHei"/>
               </a:rPr>
               <a:t>套餐外单独模块以标价为准,成交价BD当面沟通</a:t>
             </a:r>
@@ -11182,7 +11182,7 @@
                 <a:solidFill>
                   <a:srgbClr val="FFFFFF"/>
                 </a:solidFill>
-                <a:latin typeface="WenQuanYi Micro Hei"/>
+                <a:latin typeface="Microsoft YaHei"/>
               </a:rPr>
               <a:t>📈 月增收测算(稳定期)</a:t>
             </a:r>
@@ -11271,7 +11271,7 @@
                 <a:solidFill>
                   <a:srgbClr val="FFFFFF"/>
                 </a:solidFill>
-                <a:latin typeface="WenQuanYi Micro Hei"/>
+                <a:latin typeface="Microsoft YaHei"/>
               </a:rPr>
               <a:t>扫码点餐省人力</a:t>
             </a:r>
@@ -11293,7 +11293,7 @@
                 <a:solidFill>
                   <a:srgbClr val="9AB4D0"/>
                 </a:solidFill>
-                <a:latin typeface="WenQuanYi Micro Hei"/>
+                <a:latin typeface="Microsoft YaHei"/>
               </a:rPr>
               <a:t>省2名兼职点单工</a:t>
             </a:r>
@@ -11338,7 +11338,7 @@
                 <a:solidFill>
                   <a:srgbClr val="FF6D00"/>
                 </a:solidFill>
-                <a:latin typeface="WenQuanYi Micro Hei"/>
+                <a:latin typeface="Microsoft YaHei"/>
               </a:rPr>
               <a:t>+¥4,000</a:t>
             </a:r>
@@ -11427,7 +11427,7 @@
                 <a:solidFill>
                   <a:srgbClr val="FFFFFF"/>
                 </a:solidFill>
-                <a:latin typeface="WenQuanYi Micro Hei"/>
+                <a:latin typeface="Microsoft YaHei"/>
               </a:rPr>
               <a:t>储值现金流回笼</a:t>
             </a:r>
@@ -11449,7 +11449,7 @@
                 <a:solidFill>
                   <a:srgbClr val="9AB4D0"/>
                 </a:solidFill>
-                <a:latin typeface="WenQuanYi Micro Hei"/>
+                <a:latin typeface="Microsoft YaHei"/>
               </a:rPr>
               <a:t>首月,锁未来消费</a:t>
             </a:r>
@@ -11494,7 +11494,7 @@
                 <a:solidFill>
                   <a:srgbClr val="FF6D00"/>
                 </a:solidFill>
-                <a:latin typeface="WenQuanYi Micro Hei"/>
+                <a:latin typeface="Microsoft YaHei"/>
               </a:rPr>
               <a:t>+¥4万入账</a:t>
             </a:r>
@@ -11583,7 +11583,7 @@
                 <a:solidFill>
                   <a:srgbClr val="FFFFFF"/>
                 </a:solidFill>
-                <a:latin typeface="WenQuanYi Micro Hei"/>
+                <a:latin typeface="Microsoft YaHei"/>
               </a:rPr>
               <a:t>会员复购提升</a:t>
             </a:r>
@@ -11605,7 +11605,7 @@
                 <a:solidFill>
                   <a:srgbClr val="9AB4D0"/>
                 </a:solidFill>
-                <a:latin typeface="WenQuanYi Micro Hei"/>
+                <a:latin typeface="Microsoft YaHei"/>
               </a:rPr>
               <a:t>800会员×复购拉动</a:t>
             </a:r>
@@ -11650,7 +11650,7 @@
                 <a:solidFill>
                   <a:srgbClr val="FF6D00"/>
                 </a:solidFill>
-                <a:latin typeface="WenQuanYi Micro Hei"/>
+                <a:latin typeface="Microsoft YaHei"/>
               </a:rPr>
               <a:t>+¥6,000</a:t>
             </a:r>
@@ -11739,7 +11739,7 @@
                 <a:solidFill>
                   <a:srgbClr val="FFFFFF"/>
                 </a:solidFill>
-                <a:latin typeface="WenQuanYi Micro Hei"/>
+                <a:latin typeface="Microsoft YaHei"/>
               </a:rPr>
               <a:t>外卖增量</a:t>
             </a:r>
@@ -11761,7 +11761,7 @@
                 <a:solidFill>
                   <a:srgbClr val="9AB4D0"/>
                 </a:solidFill>
-                <a:latin typeface="WenQuanYi Micro Hei"/>
+                <a:latin typeface="Microsoft YaHei"/>
               </a:rPr>
               <a:t>第2周上线新增渠道</a:t>
             </a:r>
@@ -11806,7 +11806,7 @@
                 <a:solidFill>
                   <a:srgbClr val="FF6D00"/>
                 </a:solidFill>
-                <a:latin typeface="WenQuanYi Micro Hei"/>
+                <a:latin typeface="Microsoft YaHei"/>
               </a:rPr>
               <a:t>+¥3,000</a:t>
             </a:r>
@@ -11895,7 +11895,7 @@
                 <a:solidFill>
                   <a:srgbClr val="FFFFFF"/>
                 </a:solidFill>
-                <a:latin typeface="WenQuanYi Micro Hei"/>
+                <a:latin typeface="Microsoft YaHei"/>
               </a:rPr>
               <a:t>💡 月经营性增收 ≈ ¥1.3万 + 储值¥4万现金回笼</a:t>
             </a:r>
@@ -11917,7 +11917,7 @@
                 <a:solidFill>
                   <a:srgbClr val="FFFFFF"/>
                 </a:solidFill>
-                <a:latin typeface="WenQuanYi Micro Hei"/>
+                <a:latin typeface="Microsoft YaHei"/>
               </a:rPr>
               <a:t>软硬件投入约¥9千 → 1个月内即可回本</a:t>
             </a:r>
@@ -11962,7 +11962,7 @@
                 <a:solidFill>
                   <a:srgbClr val="AAB2BC"/>
                 </a:solidFill>
-                <a:latin typeface="WenQuanYi Micro Hei"/>
+                <a:latin typeface="Microsoft YaHei"/>
               </a:rPr>
               <a:t>新豪仔小龙虾烧烤融合菜 · 数字化经营解决方案</a:t>
             </a:r>
@@ -12007,7 +12007,7 @@
                 <a:solidFill>
                   <a:srgbClr val="6B7280"/>
                 </a:solidFill>
-                <a:latin typeface="WenQuanYi Micro Hei"/>
+                <a:latin typeface="Microsoft YaHei"/>
               </a:rPr>
               <a:t>13</a:t>
             </a:r>
@@ -12166,7 +12166,7 @@
                 <a:solidFill>
                   <a:srgbClr val="FFFFFF"/>
                 </a:solidFill>
-                <a:latin typeface="WenQuanYi Micro Hei"/>
+                <a:latin typeface="Microsoft YaHei"/>
               </a:rPr>
               <a:t>新豪仔小龙虾 × 美团收银</a:t>
             </a:r>
@@ -12188,7 +12188,7 @@
                 <a:solidFill>
                   <a:srgbClr val="FF9A4A"/>
                 </a:solidFill>
-                <a:latin typeface="WenQuanYi Micro Hei"/>
+                <a:latin typeface="Microsoft YaHei"/>
               </a:rPr>
               <a:t>让新店从开业第一天就赢在数字化</a:t>
             </a:r>
@@ -12284,7 +12284,7 @@
                 <a:solidFill>
                   <a:srgbClr val="FF6D00"/>
                 </a:solidFill>
-                <a:latin typeface="WenQuanYi Micro Hei"/>
+                <a:latin typeface="Microsoft YaHei"/>
               </a:rPr>
               <a:t>🚀</a:t>
             </a:r>
@@ -12329,7 +12329,7 @@
                 <a:solidFill>
                   <a:srgbClr val="FFFFFF"/>
                 </a:solidFill>
-                <a:latin typeface="WenQuanYi Micro Hei"/>
+                <a:latin typeface="Microsoft YaHei"/>
               </a:rPr>
               <a:t>开业即用</a:t>
             </a:r>
@@ -12374,7 +12374,7 @@
                 <a:solidFill>
                   <a:srgbClr val="B8CBE0"/>
                 </a:solidFill>
-                <a:latin typeface="WenQuanYi Micro Hei"/>
+                <a:latin typeface="Microsoft YaHei"/>
               </a:rPr>
               <a:t>抢90天新店红利</a:t>
             </a:r>
@@ -12470,7 +12470,7 @@
                 <a:solidFill>
                   <a:srgbClr val="FF6D00"/>
                 </a:solidFill>
-                <a:latin typeface="WenQuanYi Micro Hei"/>
+                <a:latin typeface="Microsoft YaHei"/>
               </a:rPr>
               <a:t>📊</a:t>
             </a:r>
@@ -12515,7 +12515,7 @@
                 <a:solidFill>
                   <a:srgbClr val="FFFFFF"/>
                 </a:solidFill>
-                <a:latin typeface="WenQuanYi Micro Hei"/>
+                <a:latin typeface="Microsoft YaHei"/>
               </a:rPr>
               <a:t>出餐不崩</a:t>
             </a:r>
@@ -12560,7 +12560,7 @@
                 <a:solidFill>
                   <a:srgbClr val="B8CBE0"/>
                 </a:solidFill>
-                <a:latin typeface="WenQuanYi Micro Hei"/>
+                <a:latin typeface="Microsoft YaHei"/>
               </a:rPr>
               <a:t>扫码点餐保高峰</a:t>
             </a:r>
@@ -12656,7 +12656,7 @@
                 <a:solidFill>
                   <a:srgbClr val="FF6D00"/>
                 </a:solidFill>
-                <a:latin typeface="WenQuanYi Micro Hei"/>
+                <a:latin typeface="Microsoft YaHei"/>
               </a:rPr>
               <a:t>💳</a:t>
             </a:r>
@@ -12701,7 +12701,7 @@
                 <a:solidFill>
                   <a:srgbClr val="FFFFFF"/>
                 </a:solidFill>
-                <a:latin typeface="WenQuanYi Micro Hei"/>
+                <a:latin typeface="Microsoft YaHei"/>
               </a:rPr>
               <a:t>锁客回款</a:t>
             </a:r>
@@ -12746,7 +12746,7 @@
                 <a:solidFill>
                   <a:srgbClr val="B8CBE0"/>
                 </a:solidFill>
-                <a:latin typeface="WenQuanYi Micro Hei"/>
+                <a:latin typeface="Microsoft YaHei"/>
               </a:rPr>
               <a:t>储值首月¥4万</a:t>
             </a:r>
@@ -12842,7 +12842,7 @@
                 <a:solidFill>
                   <a:srgbClr val="FF6D00"/>
                 </a:solidFill>
-                <a:latin typeface="WenQuanYi Micro Hei"/>
+                <a:latin typeface="Microsoft YaHei"/>
               </a:rPr>
               <a:t>🔁</a:t>
             </a:r>
@@ -12887,7 +12887,7 @@
                 <a:solidFill>
                   <a:srgbClr val="FFFFFF"/>
                 </a:solidFill>
-                <a:latin typeface="WenQuanYi Micro Hei"/>
+                <a:latin typeface="Microsoft YaHei"/>
               </a:rPr>
               <a:t>公私域闭环</a:t>
             </a:r>
@@ -12932,7 +12932,7 @@
                 <a:solidFill>
                   <a:srgbClr val="B8CBE0"/>
                 </a:solidFill>
-                <a:latin typeface="WenQuanYi Micro Hei"/>
+                <a:latin typeface="Microsoft YaHei"/>
               </a:rPr>
               <a:t>广告费只花一次</a:t>
             </a:r>
@@ -13028,7 +13028,7 @@
                 <a:solidFill>
                   <a:srgbClr val="FF6D00"/>
                 </a:solidFill>
-                <a:latin typeface="WenQuanYi Micro Hei"/>
+                <a:latin typeface="Microsoft YaHei"/>
               </a:rPr>
               <a:t>⭐</a:t>
             </a:r>
@@ -13073,7 +13073,7 @@
                 <a:solidFill>
                   <a:srgbClr val="FFFFFF"/>
                 </a:solidFill>
-                <a:latin typeface="WenQuanYi Micro Hei"/>
+                <a:latin typeface="Microsoft YaHei"/>
               </a:rPr>
               <a:t>口碑立住</a:t>
             </a:r>
@@ -13118,7 +13118,7 @@
                 <a:solidFill>
                   <a:srgbClr val="B8CBE0"/>
                 </a:solidFill>
-                <a:latin typeface="WenQuanYi Micro Hei"/>
+                <a:latin typeface="Microsoft YaHei"/>
               </a:rPr>
               <a:t>点评冲4.5★</a:t>
             </a:r>
@@ -13163,7 +13163,7 @@
                 <a:solidFill>
                   <a:srgbClr val="FFFFFF"/>
                 </a:solidFill>
-                <a:latin typeface="WenQuanYi Micro Hei"/>
+                <a:latin typeface="Microsoft YaHei"/>
               </a:rPr>
               <a:t>开业只有一次,数字化底座要在第一天就打好。</a:t>
             </a:r>
@@ -13185,7 +13185,7 @@
                 <a:solidFill>
                   <a:srgbClr val="9AACC2"/>
                 </a:solidFill>
-                <a:latin typeface="WenQuanYi Micro Hei"/>
+                <a:latin typeface="Microsoft YaHei"/>
               </a:rPr>
               <a:t>美团餐饮SaaS运营策划团队  |  2026年6月</a:t>
             </a:r>
@@ -13388,7 +13388,7 @@
                 <a:solidFill>
                   <a:srgbClr val="B8CBE0"/>
                 </a:solidFill>
-                <a:latin typeface="WenQuanYi Micro Hei"/>
+                <a:latin typeface="Microsoft YaHei"/>
               </a:rPr>
               <a:t>OVERVIEW · 方案导读</a:t>
             </a:r>
@@ -13433,7 +13433,7 @@
                 <a:solidFill>
                   <a:srgbClr val="FFFFFF"/>
                 </a:solidFill>
-                <a:latin typeface="WenQuanYi Micro Hei"/>
+                <a:latin typeface="Microsoft YaHei"/>
               </a:rPr>
               <a:t>为什么开业前就要把数字化打好底座？</a:t>
             </a:r>
@@ -13478,7 +13478,7 @@
                 <a:solidFill>
                   <a:srgbClr val="222A33"/>
                 </a:solidFill>
-                <a:latin typeface="WenQuanYi Micro Hei"/>
+                <a:latin typeface="Microsoft YaHei"/>
               </a:rPr>
               <a:t>你的店还没开业，正处于「建联挖需」阶段——这恰恰是最好的时机。</a:t>
             </a:r>
@@ -13500,7 +13500,7 @@
                 <a:solidFill>
                   <a:srgbClr val="6B7280"/>
                 </a:solidFill>
-                <a:latin typeface="WenQuanYi Micro Hei"/>
+                <a:latin typeface="Microsoft YaHei"/>
               </a:rPr>
               <a:t>大众点评对新店有90天流量加权、外卖前7天有扶持，错过就要花3倍预算去抢回来。</a:t>
             </a:r>
@@ -13684,7 +13684,7 @@
                 <a:solidFill>
                   <a:srgbClr val="FFFFFF"/>
                 </a:solidFill>
-                <a:latin typeface="WenQuanYi Micro Hei"/>
+                <a:latin typeface="Microsoft YaHei"/>
               </a:rPr>
               <a:t>⏰</a:t>
             </a:r>
@@ -13773,7 +13773,7 @@
                 <a:solidFill>
                   <a:srgbClr val="FFFFFF"/>
                 </a:solidFill>
-                <a:latin typeface="WenQuanYi Micro Hei"/>
+                <a:latin typeface="Microsoft YaHei"/>
               </a:rPr>
               <a:t>抢</a:t>
             </a:r>
@@ -13818,7 +13818,7 @@
                 <a:solidFill>
                   <a:srgbClr val="122A4A"/>
                 </a:solidFill>
-                <a:latin typeface="WenQuanYi Micro Hei"/>
+                <a:latin typeface="Microsoft YaHei"/>
               </a:rPr>
               <a:t>只有一次的新店红利</a:t>
             </a:r>
@@ -13863,7 +13863,7 @@
                 <a:solidFill>
                   <a:srgbClr val="222A33"/>
                 </a:solidFill>
-                <a:latin typeface="WenQuanYi Micro Hei"/>
+                <a:latin typeface="Microsoft YaHei"/>
               </a:rPr>
               <a:t>点评90天流量加权+外卖7天扶持。开业即用收银+扫码点餐+会员，等于免费拿一波公域曝光。</a:t>
             </a:r>
@@ -14047,7 +14047,7 @@
                 <a:solidFill>
                   <a:srgbClr val="FFFFFF"/>
                 </a:solidFill>
-                <a:latin typeface="WenQuanYi Micro Hei"/>
+                <a:latin typeface="Microsoft YaHei"/>
               </a:rPr>
               <a:t>📉</a:t>
             </a:r>
@@ -14136,7 +14136,7 @@
                 <a:solidFill>
                   <a:srgbClr val="FFFFFF"/>
                 </a:solidFill>
-                <a:latin typeface="WenQuanYi Micro Hei"/>
+                <a:latin typeface="Microsoft YaHei"/>
               </a:rPr>
               <a:t>防</a:t>
             </a:r>
@@ -14181,7 +14181,7 @@
                 <a:solidFill>
                   <a:srgbClr val="122A4A"/>
                 </a:solidFill>
-                <a:latin typeface="WenQuanYi Micro Hei"/>
+                <a:latin typeface="Microsoft YaHei"/>
               </a:rPr>
               <a:t>开业即巅峰的陷阱</a:t>
             </a:r>
@@ -14226,7 +14226,7 @@
                 <a:solidFill>
                   <a:srgbClr val="222A33"/>
                 </a:solidFill>
-                <a:latin typeface="WenQuanYi Micro Hei"/>
+                <a:latin typeface="Microsoft YaHei"/>
               </a:rPr>
               <a:t>烧烤店头号死法：开业打骨折→人爆满→出餐崩→差评暴增。前10条评价决定后面所有顾客印象。</a:t>
             </a:r>
@@ -14410,7 +14410,7 @@
                 <a:solidFill>
                   <a:srgbClr val="FFFFFF"/>
                 </a:solidFill>
-                <a:latin typeface="WenQuanYi Micro Hei"/>
+                <a:latin typeface="Microsoft YaHei"/>
               </a:rPr>
               <a:t>💰</a:t>
             </a:r>
@@ -14499,7 +14499,7 @@
                 <a:solidFill>
                   <a:srgbClr val="FFFFFF"/>
                 </a:solidFill>
-                <a:latin typeface="WenQuanYi Micro Hei"/>
+                <a:latin typeface="Microsoft YaHei"/>
               </a:rPr>
               <a:t>锁</a:t>
             </a:r>
@@ -14544,7 +14544,7 @@
                 <a:solidFill>
                   <a:srgbClr val="122A4A"/>
                 </a:solidFill>
-                <a:latin typeface="WenQuanYi Micro Hei"/>
+                <a:latin typeface="Microsoft YaHei"/>
               </a:rPr>
               <a:t>现金流回笼靠储值</a:t>
             </a:r>
@@ -14589,7 +14589,7 @@
                 <a:solidFill>
                   <a:srgbClr val="222A33"/>
                 </a:solidFill>
-                <a:latin typeface="WenQuanYi Micro Hei"/>
+                <a:latin typeface="Microsoft YaHei"/>
               </a:rPr>
               <a:t>¥80客单的烧烤夜宵复购频次高，开业2-3周推储值，把首月15-20%营业额提前锁进账户。</a:t>
             </a:r>
@@ -14773,7 +14773,7 @@
                 <a:solidFill>
                   <a:srgbClr val="FFFFFF"/>
                 </a:solidFill>
-                <a:latin typeface="WenQuanYi Micro Hei"/>
+                <a:latin typeface="Microsoft YaHei"/>
               </a:rPr>
               <a:t>🔁</a:t>
             </a:r>
@@ -14862,7 +14862,7 @@
                 <a:solidFill>
                   <a:srgbClr val="FFFFFF"/>
                 </a:solidFill>
-                <a:latin typeface="WenQuanYi Micro Hei"/>
+                <a:latin typeface="Microsoft YaHei"/>
               </a:rPr>
               <a:t>沉</a:t>
             </a:r>
@@ -14907,7 +14907,7 @@
                 <a:solidFill>
                   <a:srgbClr val="122A4A"/>
                 </a:solidFill>
-                <a:latin typeface="WenQuanYi Micro Hei"/>
+                <a:latin typeface="Microsoft YaHei"/>
               </a:rPr>
               <a:t>一次获客反复用</a:t>
             </a:r>
@@ -14952,7 +14952,7 @@
                 <a:solidFill>
                   <a:srgbClr val="222A33"/>
                 </a:solidFill>
-                <a:latin typeface="WenQuanYi Micro Hei"/>
+                <a:latin typeface="Microsoft YaHei"/>
               </a:rPr>
               <a:t>桌贴码扫码点餐自动入会，把开业涌入的客人沉淀成私域，后续唤醒不花一分广告费。</a:t>
             </a:r>
@@ -14997,7 +14997,7 @@
                 <a:solidFill>
                   <a:srgbClr val="AAB2BC"/>
                 </a:solidFill>
-                <a:latin typeface="WenQuanYi Micro Hei"/>
+                <a:latin typeface="Microsoft YaHei"/>
               </a:rPr>
               <a:t>新豪仔小龙虾烧烤融合菜 · 数字化经营解决方案</a:t>
             </a:r>
@@ -15042,7 +15042,7 @@
                 <a:solidFill>
                   <a:srgbClr val="6B7280"/>
                 </a:solidFill>
-                <a:latin typeface="WenQuanYi Micro Hei"/>
+                <a:latin typeface="Microsoft YaHei"/>
               </a:rPr>
               <a:t>02</a:t>
             </a:r>
@@ -15245,7 +15245,7 @@
                 <a:solidFill>
                   <a:srgbClr val="B8CBE0"/>
                 </a:solidFill>
-                <a:latin typeface="WenQuanYi Micro Hei"/>
+                <a:latin typeface="Microsoft YaHei"/>
               </a:rPr>
               <a:t>DIAGNOSIS · 门店诊断</a:t>
             </a:r>
@@ -15290,7 +15290,7 @@
                 <a:solidFill>
                   <a:srgbClr val="FFFFFF"/>
                 </a:solidFill>
-                <a:latin typeface="WenQuanYi Micro Hei"/>
+                <a:latin typeface="Microsoft YaHei"/>
               </a:rPr>
               <a:t>门店画像 &amp; 数据基石</a:t>
             </a:r>
@@ -15299,7 +15299,7 @@
                 <a:solidFill>
                   <a:srgbClr val="FFB87A"/>
                 </a:solidFill>
-                <a:latin typeface="WenQuanYi Micro Hei"/>
+                <a:latin typeface="Microsoft YaHei"/>
               </a:rPr>
               <a:t>   ⚠️未开业·数据为行业模型测算</a:t>
             </a:r>
@@ -15395,7 +15395,7 @@
                 <a:solidFill>
                   <a:srgbClr val="122A4A"/>
                 </a:solidFill>
-                <a:latin typeface="WenQuanYi Micro Hei"/>
+                <a:latin typeface="Microsoft YaHei"/>
               </a:rPr>
               <a:t>🏪 门店基础画像</a:t>
             </a:r>
@@ -15484,7 +15484,7 @@
                 <a:solidFill>
                   <a:srgbClr val="FF6D00"/>
                 </a:solidFill>
-                <a:latin typeface="WenQuanYi Micro Hei"/>
+                <a:latin typeface="Microsoft YaHei"/>
               </a:rPr>
               <a:t>品类定位</a:t>
             </a:r>
@@ -15529,7 +15529,7 @@
                 <a:solidFill>
                   <a:srgbClr val="222A33"/>
                 </a:solidFill>
-                <a:latin typeface="WenQuanYi Micro Hei"/>
+                <a:latin typeface="Microsoft YaHei"/>
               </a:rPr>
               <a:t>小龙虾+烧烤+融合菜（特色菜·正餐）</a:t>
             </a:r>
@@ -15618,7 +15618,7 @@
                 <a:solidFill>
                   <a:srgbClr val="FF6D00"/>
                 </a:solidFill>
-                <a:latin typeface="WenQuanYi Micro Hei"/>
+                <a:latin typeface="Microsoft YaHei"/>
               </a:rPr>
               <a:t>位置</a:t>
             </a:r>
@@ -15663,7 +15663,7 @@
                 <a:solidFill>
                   <a:srgbClr val="222A33"/>
                 </a:solidFill>
-                <a:latin typeface="WenQuanYi Micro Hei"/>
+                <a:latin typeface="Microsoft YaHei"/>
               </a:rPr>
               <a:t>杭州滨江·长河街道 金铂湾大厦</a:t>
             </a:r>
@@ -15752,7 +15752,7 @@
                 <a:solidFill>
                   <a:srgbClr val="FF6D00"/>
                 </a:solidFill>
-                <a:latin typeface="WenQuanYi Micro Hei"/>
+                <a:latin typeface="Microsoft YaHei"/>
               </a:rPr>
               <a:t>面积</a:t>
             </a:r>
@@ -15797,7 +15797,7 @@
                 <a:solidFill>
                   <a:srgbClr val="222A33"/>
                 </a:solidFill>
-                <a:latin typeface="WenQuanYi Micro Hei"/>
+                <a:latin typeface="Microsoft YaHei"/>
               </a:rPr>
               <a:t>200㎡ ≈ 60–75座（含夜宵外摆潜力）</a:t>
             </a:r>
@@ -15886,7 +15886,7 @@
                 <a:solidFill>
                   <a:srgbClr val="FF6D00"/>
                 </a:solidFill>
-                <a:latin typeface="WenQuanYi Micro Hei"/>
+                <a:latin typeface="Microsoft YaHei"/>
               </a:rPr>
               <a:t>人均</a:t>
             </a:r>
@@ -15931,7 +15931,7 @@
                 <a:solidFill>
                   <a:srgbClr val="222A33"/>
                 </a:solidFill>
-                <a:latin typeface="WenQuanYi Micro Hei"/>
+                <a:latin typeface="Microsoft YaHei"/>
               </a:rPr>
               <a:t>¥80（精品烧烤档，高于街边摊）</a:t>
             </a:r>
@@ -16020,7 +16020,7 @@
                 <a:solidFill>
                   <a:srgbClr val="FF6D00"/>
                 </a:solidFill>
-                <a:latin typeface="WenQuanYi Micro Hei"/>
+                <a:latin typeface="Microsoft YaHei"/>
               </a:rPr>
               <a:t>阶段</a:t>
             </a:r>
@@ -16065,7 +16065,7 @@
                 <a:solidFill>
                   <a:srgbClr val="222A33"/>
                 </a:solidFill>
-                <a:latin typeface="WenQuanYi Micro Hei"/>
+                <a:latin typeface="Microsoft YaHei"/>
               </a:rPr>
               <a:t>未开业新店 · 建联挖需 · 0–30天</a:t>
             </a:r>
@@ -16154,7 +16154,7 @@
                 <a:solidFill>
                   <a:srgbClr val="FF6D00"/>
                 </a:solidFill>
-                <a:latin typeface="WenQuanYi Micro Hei"/>
+                <a:latin typeface="Microsoft YaHei"/>
               </a:rPr>
               <a:t>SaaS</a:t>
             </a:r>
@@ -16199,7 +16199,7 @@
                 <a:solidFill>
                   <a:srgbClr val="222A33"/>
                 </a:solidFill>
-                <a:latin typeface="WenQuanYi Micro Hei"/>
+                <a:latin typeface="Microsoft YaHei"/>
               </a:rPr>
               <a:t>智能版收银（假设含基础会员+扫码点餐）</a:t>
             </a:r>
@@ -16288,7 +16288,7 @@
                 <a:solidFill>
                   <a:srgbClr val="FF6D00"/>
                 </a:solidFill>
-                <a:latin typeface="WenQuanYi Micro Hei"/>
+                <a:latin typeface="Microsoft YaHei"/>
               </a:rPr>
               <a:t>KP/触达</a:t>
             </a:r>
@@ -16333,7 +16333,7 @@
                 <a:solidFill>
                   <a:srgbClr val="222A33"/>
                 </a:solidFill>
-                <a:latin typeface="WenQuanYi Micro Hei"/>
+                <a:latin typeface="Microsoft YaHei"/>
               </a:rPr>
               <a:t>已有联系方式，KP待建联确认</a:t>
             </a:r>
@@ -16429,7 +16429,7 @@
                 <a:solidFill>
                   <a:srgbClr val="FFFFFF"/>
                 </a:solidFill>
-                <a:latin typeface="WenQuanYi Micro Hei"/>
+                <a:latin typeface="Microsoft YaHei"/>
               </a:rPr>
               <a:t>📊 数据基石（行业模型测算·开业后校准）</a:t>
             </a:r>
@@ -16474,7 +16474,7 @@
                 <a:solidFill>
                   <a:srgbClr val="FFC89A"/>
                 </a:solidFill>
-                <a:latin typeface="WenQuanYi Micro Hei"/>
+                <a:latin typeface="Microsoft YaHei"/>
               </a:rPr>
               <a:t>⚠️假设：滨江夜宵烧烤店稳定期日均35–45桌，2.5人/桌</a:t>
             </a:r>
@@ -16563,7 +16563,7 @@
                 <a:solidFill>
                   <a:srgbClr val="FF6D00"/>
                 </a:solidFill>
-                <a:latin typeface="WenQuanYi Micro Hei"/>
+                <a:latin typeface="Microsoft YaHei"/>
               </a:rPr>
               <a:t>¥80</a:t>
             </a:r>
@@ -16608,7 +16608,7 @@
                 <a:solidFill>
                   <a:srgbClr val="FFFFFF"/>
                 </a:solidFill>
-                <a:latin typeface="WenQuanYi Micro Hei"/>
+                <a:latin typeface="Microsoft YaHei"/>
               </a:rPr>
               <a:t>客单价</a:t>
             </a:r>
@@ -16653,7 +16653,7 @@
                 <a:solidFill>
                   <a:srgbClr val="9AB4D0"/>
                 </a:solidFill>
-                <a:latin typeface="WenQuanYi Micro Hei"/>
+                <a:latin typeface="Microsoft YaHei"/>
               </a:rPr>
               <a:t>门店给定</a:t>
             </a:r>
@@ -16742,7 +16742,7 @@
                 <a:solidFill>
                   <a:srgbClr val="FF6D00"/>
                 </a:solidFill>
-                <a:latin typeface="WenQuanYi Micro Hei"/>
+                <a:latin typeface="Microsoft YaHei"/>
               </a:rPr>
               <a:t>≈40桌</a:t>
             </a:r>
@@ -16787,7 +16787,7 @@
                 <a:solidFill>
                   <a:srgbClr val="FFFFFF"/>
                 </a:solidFill>
-                <a:latin typeface="WenQuanYi Micro Hei"/>
+                <a:latin typeface="Microsoft YaHei"/>
               </a:rPr>
               <a:t>稳定期日均桌</a:t>
             </a:r>
@@ -16832,7 +16832,7 @@
                 <a:solidFill>
                   <a:srgbClr val="9AB4D0"/>
                 </a:solidFill>
-                <a:latin typeface="WenQuanYi Micro Hei"/>
+                <a:latin typeface="Microsoft YaHei"/>
               </a:rPr>
               <a:t>200㎡夜宵模型</a:t>
             </a:r>
@@ -16921,7 +16921,7 @@
                 <a:solidFill>
                   <a:srgbClr val="FF6D00"/>
                 </a:solidFill>
-                <a:latin typeface="WenQuanYi Micro Hei"/>
+                <a:latin typeface="Microsoft YaHei"/>
               </a:rPr>
               <a:t>≈100人次</a:t>
             </a:r>
@@ -16966,7 +16966,7 @@
                 <a:solidFill>
                   <a:srgbClr val="FFFFFF"/>
                 </a:solidFill>
-                <a:latin typeface="WenQuanYi Micro Hei"/>
+                <a:latin typeface="Microsoft YaHei"/>
               </a:rPr>
               <a:t>日均消费人次</a:t>
             </a:r>
@@ -17011,7 +17011,7 @@
                 <a:solidFill>
                   <a:srgbClr val="9AB4D0"/>
                 </a:solidFill>
-                <a:latin typeface="WenQuanYi Micro Hei"/>
+                <a:latin typeface="Microsoft YaHei"/>
               </a:rPr>
               <a:t>40桌×2.5人</a:t>
             </a:r>
@@ -17100,7 +17100,7 @@
                 <a:solidFill>
                   <a:srgbClr val="FF6D00"/>
                 </a:solidFill>
-                <a:latin typeface="WenQuanYi Micro Hei"/>
+                <a:latin typeface="Microsoft YaHei"/>
               </a:rPr>
               <a:t>¥8K/天</a:t>
             </a:r>
@@ -17145,7 +17145,7 @@
                 <a:solidFill>
                   <a:srgbClr val="FFFFFF"/>
                 </a:solidFill>
-                <a:latin typeface="WenQuanYi Micro Hei"/>
+                <a:latin typeface="Microsoft YaHei"/>
               </a:rPr>
               <a:t>稳定期日营业额</a:t>
             </a:r>
@@ -17190,7 +17190,7 @@
                 <a:solidFill>
                   <a:srgbClr val="9AB4D0"/>
                 </a:solidFill>
-                <a:latin typeface="WenQuanYi Micro Hei"/>
+                <a:latin typeface="Microsoft YaHei"/>
               </a:rPr>
               <a:t>100×¥80</a:t>
             </a:r>
@@ -17279,7 +17279,7 @@
                 <a:solidFill>
                   <a:srgbClr val="FF6D00"/>
                 </a:solidFill>
-                <a:latin typeface="WenQuanYi Micro Hei"/>
+                <a:latin typeface="Microsoft YaHei"/>
               </a:rPr>
               <a:t>≈¥24万</a:t>
             </a:r>
@@ -17324,7 +17324,7 @@
                 <a:solidFill>
                   <a:srgbClr val="FFFFFF"/>
                 </a:solidFill>
-                <a:latin typeface="WenQuanYi Micro Hei"/>
+                <a:latin typeface="Microsoft YaHei"/>
               </a:rPr>
               <a:t>稳定期月营业额</a:t>
             </a:r>
@@ -17369,7 +17369,7 @@
                 <a:solidFill>
                   <a:srgbClr val="9AB4D0"/>
                 </a:solidFill>
-                <a:latin typeface="WenQuanYi Micro Hei"/>
+                <a:latin typeface="Microsoft YaHei"/>
               </a:rPr>
               <a:t>¥8K×30目标</a:t>
             </a:r>
@@ -17458,7 +17458,7 @@
                 <a:solidFill>
                   <a:srgbClr val="FF6D00"/>
                 </a:solidFill>
-                <a:latin typeface="WenQuanYi Micro Hei"/>
+                <a:latin typeface="Microsoft YaHei"/>
               </a:rPr>
               <a:t>3000</a:t>
             </a:r>
@@ -17503,7 +17503,7 @@
                 <a:solidFill>
                   <a:srgbClr val="FFFFFF"/>
                 </a:solidFill>
-                <a:latin typeface="WenQuanYi Micro Hei"/>
+                <a:latin typeface="Microsoft YaHei"/>
               </a:rPr>
               <a:t>月消费人次</a:t>
             </a:r>
@@ -17548,7 +17548,7 @@
                 <a:solidFill>
                   <a:srgbClr val="9AB4D0"/>
                 </a:solidFill>
-                <a:latin typeface="WenQuanYi Micro Hei"/>
+                <a:latin typeface="Microsoft YaHei"/>
               </a:rPr>
               <a:t>100×30 校验✅</a:t>
             </a:r>
@@ -17593,7 +17593,7 @@
                 <a:solidFill>
                   <a:srgbClr val="AAB2BC"/>
                 </a:solidFill>
-                <a:latin typeface="WenQuanYi Micro Hei"/>
+                <a:latin typeface="Microsoft YaHei"/>
               </a:rPr>
               <a:t>新豪仔小龙虾烧烤融合菜 · 数字化经营解决方案</a:t>
             </a:r>
@@ -17638,7 +17638,7 @@
                 <a:solidFill>
                   <a:srgbClr val="6B7280"/>
                 </a:solidFill>
-                <a:latin typeface="WenQuanYi Micro Hei"/>
+                <a:latin typeface="Microsoft YaHei"/>
               </a:rPr>
               <a:t>03</a:t>
             </a:r>
@@ -17841,7 +17841,7 @@
                 <a:solidFill>
                   <a:srgbClr val="B8CBE0"/>
                 </a:solidFill>
-                <a:latin typeface="WenQuanYi Micro Hei"/>
+                <a:latin typeface="Microsoft YaHei"/>
               </a:rPr>
               <a:t>INSIGHT · 品类洞察</a:t>
             </a:r>
@@ -17886,7 +17886,7 @@
                 <a:solidFill>
                   <a:srgbClr val="FFFFFF"/>
                 </a:solidFill>
-                <a:latin typeface="WenQuanYi Micro Hei"/>
+                <a:latin typeface="Microsoft YaHei"/>
               </a:rPr>
               <a:t>烧烤融合菜的机遇与开业期挑战</a:t>
             </a:r>
@@ -18070,7 +18070,7 @@
                 <a:solidFill>
                   <a:srgbClr val="FFFFFF"/>
                 </a:solidFill>
-                <a:latin typeface="WenQuanYi Micro Hei"/>
+                <a:latin typeface="Microsoft YaHei"/>
               </a:rPr>
               <a:t>⚠️ 开业期挑战（不解决=开业即巅峰）</a:t>
             </a:r>
@@ -18115,7 +18115,7 @@
                 <a:solidFill>
                   <a:srgbClr val="E53A3A"/>
                 </a:solidFill>
-                <a:latin typeface="WenQuanYi Micro Hei"/>
+                <a:latin typeface="Microsoft YaHei"/>
               </a:rPr>
               <a:t>● </a:t>
             </a:r>
@@ -18124,7 +18124,7 @@
                 <a:solidFill>
                   <a:srgbClr val="222A33"/>
                 </a:solidFill>
-                <a:latin typeface="WenQuanYi Micro Hei"/>
+                <a:latin typeface="Microsoft YaHei"/>
               </a:rPr>
               <a:t>零评价零口碑起步</a:t>
             </a:r>
@@ -18146,7 +18146,7 @@
                 <a:solidFill>
                   <a:srgbClr val="6B7280"/>
                 </a:solidFill>
-                <a:latin typeface="WenQuanYi Micro Hei"/>
+                <a:latin typeface="Microsoft YaHei"/>
               </a:rPr>
               <a:t>   新店点评0评价，前10条评价定调，搞砸全盘皆输</a:t>
             </a:r>
@@ -18191,7 +18191,7 @@
                 <a:solidFill>
                   <a:srgbClr val="E53A3A"/>
                 </a:solidFill>
-                <a:latin typeface="WenQuanYi Micro Hei"/>
+                <a:latin typeface="Microsoft YaHei"/>
               </a:rPr>
               <a:t>● </a:t>
             </a:r>
@@ -18200,7 +18200,7 @@
                 <a:solidFill>
                   <a:srgbClr val="222A33"/>
                 </a:solidFill>
-                <a:latin typeface="WenQuanYi Micro Hei"/>
+                <a:latin typeface="Microsoft YaHei"/>
               </a:rPr>
               <a:t>出餐崩溃风险</a:t>
             </a:r>
@@ -18222,7 +18222,7 @@
                 <a:solidFill>
                   <a:srgbClr val="6B7280"/>
                 </a:solidFill>
-                <a:latin typeface="WenQuanYi Micro Hei"/>
+                <a:latin typeface="Microsoft YaHei"/>
               </a:rPr>
               <a:t>   小龙虾+烧烤现制慢，开业人爆满→等位40分钟→差评</a:t>
             </a:r>
@@ -18267,7 +18267,7 @@
                 <a:solidFill>
                   <a:srgbClr val="E53A3A"/>
                 </a:solidFill>
-                <a:latin typeface="WenQuanYi Micro Hei"/>
+                <a:latin typeface="Microsoft YaHei"/>
               </a:rPr>
               <a:t>● </a:t>
             </a:r>
@@ -18276,7 +18276,7 @@
                 <a:solidFill>
                   <a:srgbClr val="222A33"/>
                 </a:solidFill>
-                <a:latin typeface="WenQuanYi Micro Hei"/>
+                <a:latin typeface="Microsoft YaHei"/>
               </a:rPr>
               <a:t>夜宵高峰人手紧</a:t>
             </a:r>
@@ -18298,7 +18298,7 @@
                 <a:solidFill>
                   <a:srgbClr val="6B7280"/>
                 </a:solidFill>
-                <a:latin typeface="WenQuanYi Micro Hei"/>
+                <a:latin typeface="Microsoft YaHei"/>
               </a:rPr>
               <a:t>   21:00–凌晨高峰点单结账忙不过来，漏单错单流失客人</a:t>
             </a:r>
@@ -18343,7 +18343,7 @@
                 <a:solidFill>
                   <a:srgbClr val="E53A3A"/>
                 </a:solidFill>
-                <a:latin typeface="WenQuanYi Micro Hei"/>
+                <a:latin typeface="Microsoft YaHei"/>
               </a:rPr>
               <a:t>● </a:t>
             </a:r>
@@ -18352,7 +18352,7 @@
                 <a:solidFill>
                   <a:srgbClr val="222A33"/>
                 </a:solidFill>
-                <a:latin typeface="WenQuanYi Micro Hei"/>
+                <a:latin typeface="Microsoft YaHei"/>
               </a:rPr>
               <a:t>旺季靠天吃饭</a:t>
             </a:r>
@@ -18374,7 +18374,7 @@
                 <a:solidFill>
                   <a:srgbClr val="6B7280"/>
                 </a:solidFill>
-                <a:latin typeface="WenQuanYi Micro Hei"/>
+                <a:latin typeface="Microsoft YaHei"/>
               </a:rPr>
               <a:t>   小龙虾季节性强（全国门店-7.7%），冬季雨季客流骤降</a:t>
             </a:r>
@@ -18419,7 +18419,7 @@
                 <a:solidFill>
                   <a:srgbClr val="E53A3A"/>
                 </a:solidFill>
-                <a:latin typeface="WenQuanYi Micro Hei"/>
+                <a:latin typeface="Microsoft YaHei"/>
               </a:rPr>
               <a:t>● </a:t>
             </a:r>
@@ -18428,7 +18428,7 @@
                 <a:solidFill>
                   <a:srgbClr val="222A33"/>
                 </a:solidFill>
-                <a:latin typeface="WenQuanYi Micro Hei"/>
+                <a:latin typeface="Microsoft YaHei"/>
               </a:rPr>
               <a:t>现金流压力大</a:t>
             </a:r>
@@ -18450,7 +18450,7 @@
                 <a:solidFill>
                   <a:srgbClr val="6B7280"/>
                 </a:solidFill>
-                <a:latin typeface="WenQuanYi Micro Hei"/>
+                <a:latin typeface="Microsoft YaHei"/>
               </a:rPr>
               <a:t>   新店投入大，只靠堂食慢慢回款，资金链易紧张</a:t>
             </a:r>
@@ -18634,7 +18634,7 @@
                 <a:solidFill>
                   <a:srgbClr val="FFFFFF"/>
                 </a:solidFill>
-                <a:latin typeface="WenQuanYi Micro Hei"/>
+                <a:latin typeface="Microsoft YaHei"/>
               </a:rPr>
               <a:t>🔥 赛道与位置机遇</a:t>
             </a:r>
@@ -18679,7 +18679,7 @@
                 <a:solidFill>
                   <a:srgbClr val="1EA06A"/>
                 </a:solidFill>
-                <a:latin typeface="WenQuanYi Micro Hei"/>
+                <a:latin typeface="Microsoft YaHei"/>
               </a:rPr>
               <a:t>● </a:t>
             </a:r>
@@ -18688,7 +18688,7 @@
                 <a:solidFill>
                   <a:srgbClr val="222A33"/>
                 </a:solidFill>
-                <a:latin typeface="WenQuanYi Micro Hei"/>
+                <a:latin typeface="Microsoft YaHei"/>
               </a:rPr>
               <a:t>烧烤大盘2840亿+8.5%</a:t>
             </a:r>
@@ -18710,7 +18710,7 @@
                 <a:solidFill>
                   <a:srgbClr val="6B7280"/>
                 </a:solidFill>
-                <a:latin typeface="WenQuanYi Micro Hei"/>
+                <a:latin typeface="Microsoft YaHei"/>
               </a:rPr>
               <a:t>   开店率&gt;关店率市场良性；融合菜避开纯小龙虾季节性下滑</a:t>
             </a:r>
@@ -18755,7 +18755,7 @@
                 <a:solidFill>
                   <a:srgbClr val="1EA06A"/>
                 </a:solidFill>
-                <a:latin typeface="WenQuanYi Micro Hei"/>
+                <a:latin typeface="Microsoft YaHei"/>
               </a:rPr>
               <a:t>● </a:t>
             </a:r>
@@ -18764,7 +18764,7 @@
                 <a:solidFill>
                   <a:srgbClr val="222A33"/>
                 </a:solidFill>
-                <a:latin typeface="WenQuanYi Micro Hei"/>
+                <a:latin typeface="Microsoft YaHei"/>
               </a:rPr>
               <a:t>滨江夜经济旺</a:t>
             </a:r>
@@ -18786,7 +18786,7 @@
                 <a:solidFill>
                   <a:srgbClr val="6B7280"/>
                 </a:solidFill>
-                <a:latin typeface="WenQuanYi Micro Hei"/>
+                <a:latin typeface="Microsoft YaHei"/>
               </a:rPr>
               <a:t>   金铂湾周边写字楼+小区密集，IT白领夜宵刚需，社区烧烤+啤酒馆受欢迎</a:t>
             </a:r>
@@ -18831,7 +18831,7 @@
                 <a:solidFill>
                   <a:srgbClr val="1EA06A"/>
                 </a:solidFill>
-                <a:latin typeface="WenQuanYi Micro Hei"/>
+                <a:latin typeface="Microsoft YaHei"/>
               </a:rPr>
               <a:t>● </a:t>
             </a:r>
@@ -18840,7 +18840,7 @@
                 <a:solidFill>
                   <a:srgbClr val="222A33"/>
                 </a:solidFill>
-                <a:latin typeface="WenQuanYi Micro Hei"/>
+                <a:latin typeface="Microsoft YaHei"/>
               </a:rPr>
               <a:t>情绪价值溢价</a:t>
             </a:r>
@@ -18862,7 +18862,7 @@
                 <a:solidFill>
                   <a:srgbClr val="6B7280"/>
                 </a:solidFill>
-                <a:latin typeface="WenQuanYi Micro Hei"/>
+                <a:latin typeface="Microsoft YaHei"/>
               </a:rPr>
               <a:t>   鲜切现烤+小龙虾+融合菜=记忆点，支撑¥80客单，高街边摊一档</a:t>
             </a:r>
@@ -18907,7 +18907,7 @@
                 <a:solidFill>
                   <a:srgbClr val="1EA06A"/>
                 </a:solidFill>
-                <a:latin typeface="WenQuanYi Micro Hei"/>
+                <a:latin typeface="Microsoft YaHei"/>
               </a:rPr>
               <a:t>● </a:t>
             </a:r>
@@ -18916,7 +18916,7 @@
                 <a:solidFill>
                   <a:srgbClr val="222A33"/>
                 </a:solidFill>
-                <a:latin typeface="WenQuanYi Micro Hei"/>
+                <a:latin typeface="Microsoft YaHei"/>
               </a:rPr>
               <a:t>酒水高毛利</a:t>
             </a:r>
@@ -18938,7 +18938,7 @@
                 <a:solidFill>
                   <a:srgbClr val="6B7280"/>
                 </a:solidFill>
-                <a:latin typeface="WenQuanYi Micro Hei"/>
+                <a:latin typeface="Microsoft YaHei"/>
               </a:rPr>
               <a:t>   啤酒/饮品毛利60–70%，夜宵场景酒水拉高客单与利润</a:t>
             </a:r>
@@ -18983,7 +18983,7 @@
                 <a:solidFill>
                   <a:srgbClr val="1EA06A"/>
                 </a:solidFill>
-                <a:latin typeface="WenQuanYi Micro Hei"/>
+                <a:latin typeface="Microsoft YaHei"/>
               </a:rPr>
               <a:t>● </a:t>
             </a:r>
@@ -18992,7 +18992,7 @@
                 <a:solidFill>
                   <a:srgbClr val="222A33"/>
                 </a:solidFill>
-                <a:latin typeface="WenQuanYi Micro Hei"/>
+                <a:latin typeface="Microsoft YaHei"/>
               </a:rPr>
               <a:t>新店流量红利</a:t>
             </a:r>
@@ -19014,7 +19014,7 @@
                 <a:solidFill>
                   <a:srgbClr val="6B7280"/>
                 </a:solidFill>
-                <a:latin typeface="WenQuanYi Micro Hei"/>
+                <a:latin typeface="Microsoft YaHei"/>
               </a:rPr>
               <a:t>   点评90天加权+外卖7天扶持，数字化工具=免费拿公域曝光</a:t>
             </a:r>
@@ -19059,7 +19059,7 @@
                 <a:solidFill>
                   <a:srgbClr val="AAB2BC"/>
                 </a:solidFill>
-                <a:latin typeface="WenQuanYi Micro Hei"/>
+                <a:latin typeface="Microsoft YaHei"/>
               </a:rPr>
               <a:t>新豪仔小龙虾烧烤融合菜 · 数字化经营解决方案</a:t>
             </a:r>
@@ -19104,7 +19104,7 @@
                 <a:solidFill>
                   <a:srgbClr val="6B7280"/>
                 </a:solidFill>
-                <a:latin typeface="WenQuanYi Micro Hei"/>
+                <a:latin typeface="Microsoft YaHei"/>
               </a:rPr>
               <a:t>04</a:t>
             </a:r>
@@ -19307,7 +19307,7 @@
                 <a:solidFill>
                   <a:srgbClr val="B8CBE0"/>
                 </a:solidFill>
-                <a:latin typeface="WenQuanYi Micro Hei"/>
+                <a:latin typeface="Microsoft YaHei"/>
               </a:rPr>
               <a:t>COMPETITION · 竞争格局</a:t>
             </a:r>
@@ -19352,7 +19352,7 @@
                 <a:solidFill>
                   <a:srgbClr val="FFFFFF"/>
                 </a:solidFill>
-                <a:latin typeface="WenQuanYi Micro Hei"/>
+                <a:latin typeface="Microsoft YaHei"/>
               </a:rPr>
               <a:t>滨江长河3公里夜宵烧烤竞对扫描</a:t>
             </a:r>
@@ -19361,7 +19361,7 @@
                 <a:solidFill>
                   <a:srgbClr val="FFB87A"/>
                 </a:solidFill>
-                <a:latin typeface="WenQuanYi Micro Hei"/>
+                <a:latin typeface="Microsoft YaHei"/>
               </a:rPr>
               <a:t>   ⚠️区域典型样本·开业前实地复核</a:t>
             </a:r>
@@ -19406,7 +19406,7 @@
                 <a:solidFill>
                   <a:srgbClr val="6B7280"/>
                 </a:solidFill>
-                <a:latin typeface="WenQuanYi Micro Hei"/>
+                <a:latin typeface="Microsoft YaHei"/>
               </a:rPr>
               <a:t>老板只关心「这条街谁跟我抢生意」。聚焦金铂湾周边小龙虾/烧烤/夜宵，找出我能切的那块蛋糕。</a:t>
             </a:r>
@@ -19497,7 +19497,7 @@
                 <a:solidFill>
                   <a:srgbClr val="FFFFFF"/>
                 </a:solidFill>
-                <a:latin typeface="WenQuanYi Micro Hei"/>
+                <a:latin typeface="Microsoft YaHei"/>
               </a:rPr>
               <a:t>竞对类型（周边典型）</a:t>
             </a:r>
@@ -19588,7 +19588,7 @@
                 <a:solidFill>
                   <a:srgbClr val="FFFFFF"/>
                 </a:solidFill>
-                <a:latin typeface="WenQuanYi Micro Hei"/>
+                <a:latin typeface="Microsoft YaHei"/>
               </a:rPr>
               <a:t>人均</a:t>
             </a:r>
@@ -19679,7 +19679,7 @@
                 <a:solidFill>
                   <a:srgbClr val="FFFFFF"/>
                 </a:solidFill>
-                <a:latin typeface="WenQuanYi Micro Hei"/>
+                <a:latin typeface="Microsoft YaHei"/>
               </a:rPr>
               <a:t>核心弱点</a:t>
             </a:r>
@@ -19770,7 +19770,7 @@
                 <a:solidFill>
                   <a:srgbClr val="FFFFFF"/>
                 </a:solidFill>
-                <a:latin typeface="WenQuanYi Micro Hei"/>
+                <a:latin typeface="Microsoft YaHei"/>
               </a:rPr>
               <a:t>新豪仔的切入机会</a:t>
             </a:r>
@@ -19861,7 +19861,7 @@
                 <a:solidFill>
                   <a:srgbClr val="222A33"/>
                 </a:solidFill>
-                <a:latin typeface="WenQuanYi Micro Hei"/>
+                <a:latin typeface="Microsoft YaHei"/>
               </a:rPr>
               <a:t>街边烧烤摊/大排档</a:t>
             </a:r>
@@ -19952,7 +19952,7 @@
                 <a:solidFill>
                   <a:srgbClr val="FF6D00"/>
                 </a:solidFill>
-                <a:latin typeface="WenQuanYi Micro Hei"/>
+                <a:latin typeface="Microsoft YaHei"/>
               </a:rPr>
               <a:t>¥40–60</a:t>
             </a:r>
@@ -20043,7 +20043,7 @@
                 <a:solidFill>
                   <a:srgbClr val="222A33"/>
                 </a:solidFill>
-                <a:latin typeface="WenQuanYi Micro Hei"/>
+                <a:latin typeface="Microsoft YaHei"/>
               </a:rPr>
               <a:t>环境差、无堂食体验、不能开票、卫生存疑</a:t>
             </a:r>
@@ -20134,7 +20134,7 @@
                 <a:solidFill>
                   <a:srgbClr val="122A4A"/>
                 </a:solidFill>
-                <a:latin typeface="WenQuanYi Micro Hei"/>
+                <a:latin typeface="Microsoft YaHei"/>
               </a:rPr>
               <a:t>「干净明档+融合菜+刷卡开票」拉高一档，抢有品质要求的白领夜宵客</a:t>
             </a:r>
@@ -20225,7 +20225,7 @@
                 <a:solidFill>
                   <a:srgbClr val="222A33"/>
                 </a:solidFill>
-                <a:latin typeface="WenQuanYi Micro Hei"/>
+                <a:latin typeface="Microsoft YaHei"/>
               </a:rPr>
               <a:t>纯小龙虾专门店</a:t>
             </a:r>
@@ -20316,7 +20316,7 @@
                 <a:solidFill>
                   <a:srgbClr val="FF6D00"/>
                 </a:solidFill>
-                <a:latin typeface="WenQuanYi Micro Hei"/>
+                <a:latin typeface="Microsoft YaHei"/>
               </a:rPr>
               <a:t>¥90–120</a:t>
             </a:r>
@@ -20407,7 +20407,7 @@
                 <a:solidFill>
                   <a:srgbClr val="222A33"/>
                 </a:solidFill>
-                <a:latin typeface="WenQuanYi Micro Hei"/>
+                <a:latin typeface="Microsoft YaHei"/>
               </a:rPr>
               <a:t>季节性强、淡季冷清、菜品单一</a:t>
             </a:r>
@@ -20498,7 +20498,7 @@
                 <a:solidFill>
                   <a:srgbClr val="122A4A"/>
                 </a:solidFill>
-                <a:latin typeface="WenQuanYi Micro Hei"/>
+                <a:latin typeface="Microsoft YaHei"/>
               </a:rPr>
               <a:t>融合菜+烧烤补全季节，一年四季有理由来，复购更稳</a:t>
             </a:r>
@@ -20589,7 +20589,7 @@
                 <a:solidFill>
                   <a:srgbClr val="222A33"/>
                 </a:solidFill>
-                <a:latin typeface="WenQuanYi Micro Hei"/>
+                <a:latin typeface="Microsoft YaHei"/>
               </a:rPr>
               <a:t>连锁烤肉/韩式烤肉</a:t>
             </a:r>
@@ -20680,7 +20680,7 @@
                 <a:solidFill>
                   <a:srgbClr val="FF6D00"/>
                 </a:solidFill>
-                <a:latin typeface="WenQuanYi Micro Hei"/>
+                <a:latin typeface="Microsoft YaHei"/>
               </a:rPr>
               <a:t>¥80–110</a:t>
             </a:r>
@@ -20771,7 +20771,7 @@
                 <a:solidFill>
                   <a:srgbClr val="222A33"/>
                 </a:solidFill>
-                <a:latin typeface="WenQuanYi Micro Hei"/>
+                <a:latin typeface="Microsoft YaHei"/>
               </a:rPr>
               <a:t>同质化、缺本地特色、排队久</a:t>
             </a:r>
@@ -20862,7 +20862,7 @@
                 <a:solidFill>
                   <a:srgbClr val="122A4A"/>
                 </a:solidFill>
-                <a:latin typeface="WenQuanYi Micro Hei"/>
+                <a:latin typeface="Microsoft YaHei"/>
               </a:rPr>
               <a:t>小龙虾差异化+夜宵酒水+扫码点餐快出餐，错位竞争</a:t>
             </a:r>
@@ -20953,7 +20953,7 @@
                 <a:solidFill>
                   <a:srgbClr val="222A33"/>
                 </a:solidFill>
-                <a:latin typeface="WenQuanYi Micro Hei"/>
+                <a:latin typeface="Microsoft YaHei"/>
               </a:rPr>
               <a:t>社区火锅/江湖菜</a:t>
             </a:r>
@@ -21044,7 +21044,7 @@
                 <a:solidFill>
                   <a:srgbClr val="FF6D00"/>
                 </a:solidFill>
-                <a:latin typeface="WenQuanYi Micro Hei"/>
+                <a:latin typeface="Microsoft YaHei"/>
               </a:rPr>
               <a:t>¥70–90</a:t>
             </a:r>
@@ -21135,7 +21135,7 @@
                 <a:solidFill>
                   <a:srgbClr val="222A33"/>
                 </a:solidFill>
-                <a:latin typeface="WenQuanYi Micro Hei"/>
+                <a:latin typeface="Microsoft YaHei"/>
               </a:rPr>
               <a:t>夏季偏热不应季、出餐慢</a:t>
             </a:r>
@@ -21226,7 +21226,7 @@
                 <a:solidFill>
                   <a:srgbClr val="122A4A"/>
                 </a:solidFill>
-                <a:latin typeface="WenQuanYi Micro Hei"/>
+                <a:latin typeface="Microsoft YaHei"/>
               </a:rPr>
               <a:t>主打「夏夜限定」小龙虾+冰啤+烧烤抢应季流量</a:t>
             </a:r>
@@ -21315,7 +21315,7 @@
                 <a:solidFill>
                   <a:srgbClr val="FF6D00"/>
                 </a:solidFill>
-                <a:latin typeface="WenQuanYi Micro Hei"/>
+                <a:latin typeface="Microsoft YaHei"/>
               </a:rPr>
               <a:t>🎯 总切入策略：</a:t>
             </a:r>
@@ -21324,7 +21324,7 @@
                 <a:solidFill>
                   <a:srgbClr val="222A33"/>
                 </a:solidFill>
-                <a:latin typeface="WenQuanYi Micro Hei"/>
+                <a:latin typeface="Microsoft YaHei"/>
               </a:rPr>
               <a:t>以「品质明档+融合菜全年款+夜宵酒水社交」错位街边摊与单一品类店，用扫码点餐解决高峰出餐，用点评/小红书把「滨江夜宵新地标」立住。</a:t>
             </a:r>
@@ -21369,7 +21369,7 @@
                 <a:solidFill>
                   <a:srgbClr val="AAB2BC"/>
                 </a:solidFill>
-                <a:latin typeface="WenQuanYi Micro Hei"/>
+                <a:latin typeface="Microsoft YaHei"/>
               </a:rPr>
               <a:t>新豪仔小龙虾烧烤融合菜 · 数字化经营解决方案</a:t>
             </a:r>
@@ -21414,7 +21414,7 @@
                 <a:solidFill>
                   <a:srgbClr val="6B7280"/>
                 </a:solidFill>
-                <a:latin typeface="WenQuanYi Micro Hei"/>
+                <a:latin typeface="Microsoft YaHei"/>
               </a:rPr>
               <a:t>05</a:t>
             </a:r>
@@ -21617,7 +21617,7 @@
                 <a:solidFill>
                   <a:srgbClr val="B8CBE0"/>
                 </a:solidFill>
-                <a:latin typeface="WenQuanYi Micro Hei"/>
+                <a:latin typeface="Microsoft YaHei"/>
               </a:rPr>
               <a:t>STRATEGY · 核心策略</a:t>
             </a:r>
@@ -21662,7 +21662,7 @@
                 <a:solidFill>
                   <a:srgbClr val="FFFFFF"/>
                 </a:solidFill>
-                <a:latin typeface="WenQuanYi Micro Hei"/>
+                <a:latin typeface="Microsoft YaHei"/>
               </a:rPr>
               <a:t>开业90天三阶段作战地图</a:t>
             </a:r>
@@ -21846,7 +21846,7 @@
                 <a:solidFill>
                   <a:srgbClr val="FFFFFF"/>
                 </a:solidFill>
-                <a:latin typeface="WenQuanYi Micro Hei"/>
+                <a:latin typeface="Microsoft YaHei"/>
               </a:rPr>
               <a:t>🚀 蓄水期</a:t>
             </a:r>
@@ -21891,7 +21891,7 @@
                 <a:solidFill>
                   <a:srgbClr val="FFFFFF"/>
                 </a:solidFill>
-                <a:latin typeface="WenQuanYi Micro Hei"/>
+                <a:latin typeface="Microsoft YaHei"/>
               </a:rPr>
               <a:t>开业前30天</a:t>
             </a:r>
@@ -21936,7 +21936,7 @@
                 <a:solidFill>
                   <a:srgbClr val="222A33"/>
                 </a:solidFill>
-                <a:latin typeface="WenQuanYi Micro Hei"/>
+                <a:latin typeface="Microsoft YaHei"/>
               </a:rPr>
               <a:t>线上线下提前蓄客500+，点评商户页+预售团购上线，企微社群搭建</a:t>
             </a:r>
@@ -22025,7 +22025,7 @@
                 <a:solidFill>
                   <a:srgbClr val="FFFFFF"/>
                 </a:solidFill>
-                <a:latin typeface="WenQuanYi Micro Hei"/>
+                <a:latin typeface="Microsoft YaHei"/>
               </a:rPr>
               <a:t>目标 蓄客500+</a:t>
             </a:r>
@@ -22209,7 +22209,7 @@
                 <a:solidFill>
                   <a:srgbClr val="FFFFFF"/>
                 </a:solidFill>
-                <a:latin typeface="WenQuanYi Micro Hei"/>
+                <a:latin typeface="Microsoft YaHei"/>
               </a:rPr>
               <a:t>🔥 引爆期</a:t>
             </a:r>
@@ -22254,7 +22254,7 @@
                 <a:solidFill>
                   <a:srgbClr val="FFFFFF"/>
                 </a:solidFill>
-                <a:latin typeface="WenQuanYi Micro Hei"/>
+                <a:latin typeface="Microsoft YaHei"/>
               </a:rPr>
               <a:t>开业1–14天</a:t>
             </a:r>
@@ -22299,7 +22299,7 @@
                 <a:solidFill>
                   <a:srgbClr val="222A33"/>
                 </a:solidFill>
-                <a:latin typeface="WenQuanYi Micro Hei"/>
+                <a:latin typeface="Microsoft YaHei"/>
               </a:rPr>
               <a:t>控流量保出餐+冲首批50条优质评价+达人探店，外卖第2周上线抢扶持</a:t>
             </a:r>
@@ -22388,7 +22388,7 @@
                 <a:solidFill>
                   <a:srgbClr val="FFFFFF"/>
                 </a:solidFill>
-                <a:latin typeface="WenQuanYi Micro Hei"/>
+                <a:latin typeface="Microsoft YaHei"/>
               </a:rPr>
               <a:t>目标 首周50评价</a:t>
             </a:r>
@@ -22572,7 +22572,7 @@
                 <a:solidFill>
                   <a:srgbClr val="FFFFFF"/>
                 </a:solidFill>
-                <a:latin typeface="WenQuanYi Micro Hei"/>
+                <a:latin typeface="Microsoft YaHei"/>
               </a:rPr>
               <a:t>💎 沉淀期</a:t>
             </a:r>
@@ -22617,7 +22617,7 @@
                 <a:solidFill>
                   <a:srgbClr val="FFFFFF"/>
                 </a:solidFill>
-                <a:latin typeface="WenQuanYi Micro Hei"/>
+                <a:latin typeface="Microsoft YaHei"/>
               </a:rPr>
               <a:t>开业15–90天</a:t>
             </a:r>
@@ -22662,7 +22662,7 @@
                 <a:solidFill>
                   <a:srgbClr val="222A33"/>
                 </a:solidFill>
-                <a:latin typeface="WenQuanYi Micro Hei"/>
+                <a:latin typeface="Microsoft YaHei"/>
               </a:rPr>
               <a:t>推储值锁客+会员复购唤醒+点评冲热门榜，公私域闭环跑通</a:t>
             </a:r>
@@ -22751,7 +22751,7 @@
                 <a:solidFill>
                   <a:srgbClr val="FFFFFF"/>
                 </a:solidFill>
-                <a:latin typeface="WenQuanYi Micro Hei"/>
+                <a:latin typeface="Microsoft YaHei"/>
               </a:rPr>
               <a:t>目标 会员500+储值¥4万</a:t>
             </a:r>
@@ -22796,7 +22796,7 @@
                 <a:solidFill>
                   <a:srgbClr val="FF6D00"/>
                 </a:solidFill>
-                <a:latin typeface="WenQuanYi Micro Hei"/>
+                <a:latin typeface="Microsoft YaHei"/>
               </a:rPr>
               <a:t>▶</a:t>
             </a:r>
@@ -22841,7 +22841,7 @@
                 <a:solidFill>
                   <a:srgbClr val="FF6D00"/>
                 </a:solidFill>
-                <a:latin typeface="WenQuanYi Micro Hei"/>
+                <a:latin typeface="Microsoft YaHei"/>
               </a:rPr>
               <a:t>▶</a:t>
             </a:r>
@@ -22886,7 +22886,7 @@
                 <a:solidFill>
                   <a:srgbClr val="122A4A"/>
                 </a:solidFill>
-                <a:latin typeface="WenQuanYi Micro Hei"/>
+                <a:latin typeface="Microsoft YaHei"/>
               </a:rPr>
               <a:t>贯穿三阶段的工具底座：</a:t>
             </a:r>
@@ -22895,7 +22895,7 @@
                 <a:solidFill>
                   <a:srgbClr val="6B7280"/>
                 </a:solidFill>
-                <a:latin typeface="WenQuanYi Micro Hei"/>
+                <a:latin typeface="Microsoft YaHei"/>
               </a:rPr>
               <a:t>智能收银 → 扫码点餐（高峰出餐）→ 会员/储值（锁客）→ 评价专家（口碑）→ 公私域联动（持续引流）</a:t>
             </a:r>
@@ -22940,7 +22940,7 @@
                 <a:solidFill>
                   <a:srgbClr val="AAB2BC"/>
                 </a:solidFill>
-                <a:latin typeface="WenQuanYi Micro Hei"/>
+                <a:latin typeface="Microsoft YaHei"/>
               </a:rPr>
               <a:t>新豪仔小龙虾烧烤融合菜 · 数字化经营解决方案</a:t>
             </a:r>
@@ -22985,7 +22985,7 @@
                 <a:solidFill>
                   <a:srgbClr val="6B7280"/>
                 </a:solidFill>
-                <a:latin typeface="WenQuanYi Micro Hei"/>
+                <a:latin typeface="Microsoft YaHei"/>
               </a:rPr>
               <a:t>06</a:t>
             </a:r>
@@ -23188,7 +23188,7 @@
                 <a:solidFill>
                   <a:srgbClr val="B8CBE0"/>
                 </a:solidFill>
-                <a:latin typeface="WenQuanYi Micro Hei"/>
+                <a:latin typeface="Microsoft YaHei"/>
               </a:rPr>
               <a:t>PRODUCT · 出餐提速</a:t>
             </a:r>
@@ -23233,7 +23233,7 @@
                 <a:solidFill>
                   <a:srgbClr val="FFFFFF"/>
                 </a:solidFill>
-                <a:latin typeface="WenQuanYi Micro Hei"/>
+                <a:latin typeface="Microsoft YaHei"/>
               </a:rPr>
               <a:t>智能收银 + 扫码点餐：夜宵高峰不崩盘</a:t>
             </a:r>
@@ -23278,7 +23278,7 @@
                 <a:solidFill>
                   <a:srgbClr val="222A33"/>
                 </a:solidFill>
-                <a:latin typeface="WenQuanYi Micro Hei"/>
+                <a:latin typeface="Microsoft YaHei"/>
               </a:rPr>
               <a:t>你的痛点：小龙虾+烧烤现制慢、21点后高峰人手紧 → 这两个功能直接解决</a:t>
             </a:r>
@@ -23462,7 +23462,7 @@
                 <a:solidFill>
                   <a:srgbClr val="FFFFFF"/>
                 </a:solidFill>
-                <a:latin typeface="WenQuanYi Micro Hei"/>
+                <a:latin typeface="Microsoft YaHei"/>
               </a:rPr>
               <a:t>📱</a:t>
             </a:r>
@@ -23507,7 +23507,7 @@
                 <a:solidFill>
                   <a:srgbClr val="FFFFFF"/>
                 </a:solidFill>
-                <a:latin typeface="WenQuanYi Micro Hei"/>
+                <a:latin typeface="Microsoft YaHei"/>
               </a:rPr>
               <a:t>扫码点餐</a:t>
             </a:r>
@@ -23552,7 +23552,7 @@
                 <a:solidFill>
                   <a:srgbClr val="222A33"/>
                 </a:solidFill>
-                <a:latin typeface="WenQuanYi Micro Hei"/>
+                <a:latin typeface="Microsoft YaHei"/>
               </a:rPr>
               <a:t>顾客扫桌码自助下单，不用等服务员；高峰期省2名点单工，出餐指令直达后厨</a:t>
             </a:r>
@@ -23641,7 +23641,7 @@
                 <a:solidFill>
                   <a:srgbClr val="FFFFFF"/>
                 </a:solidFill>
-                <a:latin typeface="WenQuanYi Micro Hei"/>
+                <a:latin typeface="Microsoft YaHei"/>
               </a:rPr>
               <a:t>高峰漏单趋零</a:t>
             </a:r>
@@ -23825,7 +23825,7 @@
                 <a:solidFill>
                   <a:srgbClr val="FFFFFF"/>
                 </a:solidFill>
-                <a:latin typeface="WenQuanYi Micro Hei"/>
+                <a:latin typeface="Microsoft YaHei"/>
               </a:rPr>
               <a:t>🖥️</a:t>
             </a:r>
@@ -23870,7 +23870,7 @@
                 <a:solidFill>
                   <a:srgbClr val="FFFFFF"/>
                 </a:solidFill>
-                <a:latin typeface="WenQuanYi Micro Hei"/>
+                <a:latin typeface="Microsoft YaHei"/>
               </a:rPr>
               <a:t>智能收银一体机</a:t>
             </a:r>
@@ -23915,7 +23915,7 @@
                 <a:solidFill>
                   <a:srgbClr val="222A33"/>
                 </a:solidFill>
-                <a:latin typeface="WenQuanYi Micro Hei"/>
+                <a:latin typeface="Microsoft YaHei"/>
               </a:rPr>
               <a:t>点单/收银/会员/库存一体，新店员上手快；支持刷卡/扫码/开发票</a:t>
             </a:r>
@@ -24004,7 +24004,7 @@
                 <a:solidFill>
                   <a:srgbClr val="FFFFFF"/>
                 </a:solidFill>
-                <a:latin typeface="WenQuanYi Micro Hei"/>
+                <a:latin typeface="Microsoft YaHei"/>
               </a:rPr>
               <a:t>收银效率↑40%</a:t>
             </a:r>
@@ -24188,7 +24188,7 @@
                 <a:solidFill>
                   <a:srgbClr val="FFFFFF"/>
                 </a:solidFill>
-                <a:latin typeface="WenQuanYi Micro Hei"/>
+                <a:latin typeface="Microsoft YaHei"/>
               </a:rPr>
               <a:t>🖨️</a:t>
             </a:r>
@@ -24233,7 +24233,7 @@
                 <a:solidFill>
                   <a:srgbClr val="FFFFFF"/>
                 </a:solidFill>
-                <a:latin typeface="WenQuanYi Micro Hei"/>
+                <a:latin typeface="Microsoft YaHei"/>
               </a:rPr>
               <a:t>后厨分单打印</a:t>
             </a:r>
@@ -24278,7 +24278,7 @@
                 <a:solidFill>
                   <a:srgbClr val="222A33"/>
                 </a:solidFill>
-                <a:latin typeface="WenQuanYi Micro Hei"/>
+                <a:latin typeface="Microsoft YaHei"/>
               </a:rPr>
               <a:t>小龙虾档/烧烤档/凉菜档自动分单，不串单、不漏菜</a:t>
             </a:r>
@@ -24367,7 +24367,7 @@
                 <a:solidFill>
                   <a:srgbClr val="FFFFFF"/>
                 </a:solidFill>
-                <a:latin typeface="WenQuanYi Micro Hei"/>
+                <a:latin typeface="Microsoft YaHei"/>
               </a:rPr>
               <a:t>出餐提速30%</a:t>
             </a:r>
@@ -24551,7 +24551,7 @@
                 <a:solidFill>
                   <a:srgbClr val="FFFFFF"/>
                 </a:solidFill>
-                <a:latin typeface="WenQuanYi Micro Hei"/>
+                <a:latin typeface="Microsoft YaHei"/>
               </a:rPr>
               <a:t>📊</a:t>
             </a:r>
@@ -24596,7 +24596,7 @@
                 <a:solidFill>
                   <a:srgbClr val="FFFFFF"/>
                 </a:solidFill>
-                <a:latin typeface="WenQuanYi Micro Hei"/>
+                <a:latin typeface="Microsoft YaHei"/>
               </a:rPr>
               <a:t>手机看经营数据</a:t>
             </a:r>
@@ -24641,7 +24641,7 @@
                 <a:solidFill>
                   <a:srgbClr val="222A33"/>
                 </a:solidFill>
-                <a:latin typeface="WenQuanYi Micro Hei"/>
+                <a:latin typeface="Microsoft YaHei"/>
               </a:rPr>
               <a:t>老板手机随时看营业额/桌数/爆款排行，不用守店</a:t>
             </a:r>
@@ -24730,7 +24730,7 @@
                 <a:solidFill>
                   <a:srgbClr val="FFFFFF"/>
                 </a:solidFill>
-                <a:latin typeface="WenQuanYi Micro Hei"/>
+                <a:latin typeface="Microsoft YaHei"/>
               </a:rPr>
               <a:t>数据决策</a:t>
             </a:r>
@@ -24826,7 +24826,7 @@
                 <a:solidFill>
                   <a:srgbClr val="FF6D00"/>
                 </a:solidFill>
-                <a:latin typeface="WenQuanYi Micro Hei"/>
+                <a:latin typeface="Microsoft YaHei"/>
               </a:rPr>
               <a:t>💡 场景化效果：</a:t>
             </a:r>
@@ -24835,7 +24835,7 @@
                 <a:solidFill>
                   <a:srgbClr val="FFFFFF"/>
                 </a:solidFill>
-                <a:latin typeface="WenQuanYi Micro Hei"/>
+                <a:latin typeface="Microsoft YaHei"/>
               </a:rPr>
               <a:t>开业首周高峰，4桌客人同时扫码下单→后厨3档分单并行→烧烤先上、小龙虾随后，</a:t>
             </a:r>
@@ -24857,7 +24857,7 @@
                 <a:solidFill>
                   <a:srgbClr val="FFFFFF"/>
                 </a:solidFill>
-                <a:latin typeface="WenQuanYi Micro Hei"/>
+                <a:latin typeface="Microsoft YaHei"/>
               </a:rPr>
               <a:t>       顾客感知「上菜快」而非「等太久」→ 直接避开烧烤店头号差评，首批评价稳住4.5★+。</a:t>
             </a:r>
@@ -24902,7 +24902,7 @@
                 <a:solidFill>
                   <a:srgbClr val="AAB2BC"/>
                 </a:solidFill>
-                <a:latin typeface="WenQuanYi Micro Hei"/>
+                <a:latin typeface="Microsoft YaHei"/>
               </a:rPr>
               <a:t>新豪仔小龙虾烧烤融合菜 · 数字化经营解决方案</a:t>
             </a:r>
@@ -24947,7 +24947,7 @@
                 <a:solidFill>
                   <a:srgbClr val="6B7280"/>
                 </a:solidFill>
-                <a:latin typeface="WenQuanYi Micro Hei"/>
+                <a:latin typeface="Microsoft YaHei"/>
               </a:rPr>
               <a:t>07</a:t>
             </a:r>
@@ -25150,7 +25150,7 @@
                 <a:solidFill>
                   <a:srgbClr val="B8CBE0"/>
                 </a:solidFill>
-                <a:latin typeface="WenQuanYi Micro Hei"/>
+                <a:latin typeface="Microsoft YaHei"/>
               </a:rPr>
               <a:t>MEMBER · 会员体系</a:t>
             </a:r>
@@ -25195,7 +25195,7 @@
                 <a:solidFill>
                   <a:srgbClr val="FFFFFF"/>
                 </a:solidFill>
-                <a:latin typeface="WenQuanYi Micro Hei"/>
+                <a:latin typeface="Microsoft YaHei"/>
               </a:rPr>
               <a:t>双层会员：储值锁客 + 等级养客</a:t>
             </a:r>
@@ -25379,7 +25379,7 @@
                 <a:solidFill>
                   <a:srgbClr val="FFFFFF"/>
                 </a:solidFill>
-                <a:latin typeface="WenQuanYi Micro Hei"/>
+                <a:latin typeface="Microsoft YaHei"/>
               </a:rPr>
               <a:t>💳 储值会员（钱包型）</a:t>
             </a:r>
@@ -25424,7 +25424,7 @@
                 <a:solidFill>
                   <a:srgbClr val="FF6D00"/>
                 </a:solidFill>
-                <a:latin typeface="WenQuanYi Micro Hei"/>
+                <a:latin typeface="Microsoft YaHei"/>
               </a:rPr>
               <a:t>▸ </a:t>
             </a:r>
@@ -25433,7 +25433,7 @@
                 <a:solidFill>
                   <a:srgbClr val="222A33"/>
                 </a:solidFill>
-                <a:latin typeface="WenQuanYi Micro Hei"/>
+                <a:latin typeface="Microsoft YaHei"/>
               </a:rPr>
               <a:t>核心：预存换优惠，锁定未来消费</a:t>
             </a:r>
@@ -25478,7 +25478,7 @@
                 <a:solidFill>
                   <a:srgbClr val="FF6D00"/>
                 </a:solidFill>
-                <a:latin typeface="WenQuanYi Micro Hei"/>
+                <a:latin typeface="Microsoft YaHei"/>
               </a:rPr>
               <a:t>▸ </a:t>
             </a:r>
@@ -25487,7 +25487,7 @@
                 <a:solidFill>
                   <a:srgbClr val="222A33"/>
                 </a:solidFill>
-                <a:latin typeface="WenQuanYi Micro Hei"/>
+                <a:latin typeface="Microsoft YaHei"/>
               </a:rPr>
               <a:t>入会：充值即开通，扫码弹窗引导</a:t>
             </a:r>
@@ -25532,7 +25532,7 @@
                 <a:solidFill>
                   <a:srgbClr val="FF6D00"/>
                 </a:solidFill>
-                <a:latin typeface="WenQuanYi Micro Hei"/>
+                <a:latin typeface="Microsoft YaHei"/>
               </a:rPr>
               <a:t>▸ </a:t>
             </a:r>
@@ -25541,7 +25541,7 @@
                 <a:solidFill>
                   <a:srgbClr val="222A33"/>
                 </a:solidFill>
-                <a:latin typeface="WenQuanYi Micro Hei"/>
+                <a:latin typeface="Microsoft YaHei"/>
               </a:rPr>
               <a:t>权益：储值专属价+赠金+生日双倍</a:t>
             </a:r>
@@ -25586,7 +25586,7 @@
                 <a:solidFill>
                   <a:srgbClr val="FF6D00"/>
                 </a:solidFill>
-                <a:latin typeface="WenQuanYi Micro Hei"/>
+                <a:latin typeface="Microsoft YaHei"/>
               </a:rPr>
               <a:t>▸ </a:t>
             </a:r>
@@ -25595,7 +25595,7 @@
                 <a:solidFill>
                   <a:srgbClr val="222A33"/>
                 </a:solidFill>
-                <a:latin typeface="WenQuanYi Micro Hei"/>
+                <a:latin typeface="Microsoft YaHei"/>
               </a:rPr>
               <a:t>目标：开业首月回笼现金流¥4万+</a:t>
             </a:r>
@@ -25779,7 +25779,7 @@
                 <a:solidFill>
                   <a:srgbClr val="FFFFFF"/>
                 </a:solidFill>
-                <a:latin typeface="WenQuanYi Micro Hei"/>
+                <a:latin typeface="Microsoft YaHei"/>
               </a:rPr>
               <a:t>⭐ 等级会员（成长型）</a:t>
             </a:r>
@@ -25824,7 +25824,7 @@
                 <a:solidFill>
                   <a:srgbClr val="1A73E8"/>
                 </a:solidFill>
-                <a:latin typeface="WenQuanYi Micro Hei"/>
+                <a:latin typeface="Microsoft YaHei"/>
               </a:rPr>
               <a:t>▸ </a:t>
             </a:r>
@@ -25833,7 +25833,7 @@
                 <a:solidFill>
                   <a:srgbClr val="222A33"/>
                 </a:solidFill>
-                <a:latin typeface="WenQuanYi Micro Hei"/>
+                <a:latin typeface="Microsoft YaHei"/>
               </a:rPr>
               <a:t>核心：累计消费升级，权益递进</a:t>
             </a:r>
@@ -25878,7 +25878,7 @@
                 <a:solidFill>
                   <a:srgbClr val="1A73E8"/>
                 </a:solidFill>
-                <a:latin typeface="WenQuanYi Micro Hei"/>
+                <a:latin typeface="Microsoft YaHei"/>
               </a:rPr>
               <a:t>▸ </a:t>
             </a:r>
@@ -25887,7 +25887,7 @@
                 <a:solidFill>
                   <a:srgbClr val="222A33"/>
                 </a:solidFill>
-                <a:latin typeface="WenQuanYi Micro Hei"/>
+                <a:latin typeface="Microsoft YaHei"/>
               </a:rPr>
               <a:t>入会：扫码点餐首单自动注册</a:t>
             </a:r>
@@ -25932,7 +25932,7 @@
                 <a:solidFill>
                   <a:srgbClr val="1A73E8"/>
                 </a:solidFill>
-                <a:latin typeface="WenQuanYi Micro Hei"/>
+                <a:latin typeface="Microsoft YaHei"/>
               </a:rPr>
               <a:t>▸ </a:t>
             </a:r>
@@ -25941,7 +25941,7 @@
                 <a:solidFill>
                   <a:srgbClr val="222A33"/>
                 </a:solidFill>
-                <a:latin typeface="WenQuanYi Micro Hei"/>
+                <a:latin typeface="Microsoft YaHei"/>
               </a:rPr>
               <a:t>权益：银卡9.5折/金卡9折+优先订位</a:t>
             </a:r>
@@ -25986,7 +25986,7 @@
                 <a:solidFill>
                   <a:srgbClr val="1A73E8"/>
                 </a:solidFill>
-                <a:latin typeface="WenQuanYi Micro Hei"/>
+                <a:latin typeface="Microsoft YaHei"/>
               </a:rPr>
               <a:t>▸ </a:t>
             </a:r>
@@ -25995,7 +25995,7 @@
                 <a:solidFill>
                   <a:srgbClr val="222A33"/>
                 </a:solidFill>
-                <a:latin typeface="WenQuanYi Micro Hei"/>
+                <a:latin typeface="Microsoft YaHei"/>
               </a:rPr>
               <a:t>目标：开业90天会员破800人</a:t>
             </a:r>
@@ -26179,7 +26179,7 @@
                 <a:solidFill>
                   <a:srgbClr val="FFFFFF"/>
                 </a:solidFill>
-                <a:latin typeface="WenQuanYi Micro Hei"/>
+                <a:latin typeface="Microsoft YaHei"/>
               </a:rPr>
               <a:t>🔗 两层联动</a:t>
             </a:r>
@@ -26224,7 +26224,7 @@
                 <a:solidFill>
                   <a:srgbClr val="1EA06A"/>
                 </a:solidFill>
-                <a:latin typeface="WenQuanYi Micro Hei"/>
+                <a:latin typeface="Microsoft YaHei"/>
               </a:rPr>
               <a:t>▸ </a:t>
             </a:r>
@@ -26233,7 +26233,7 @@
                 <a:solidFill>
                   <a:srgbClr val="222A33"/>
                 </a:solidFill>
-                <a:latin typeface="WenQuanYi Micro Hei"/>
+                <a:latin typeface="Microsoft YaHei"/>
               </a:rPr>
               <a:t>储值解决「锁客」，等级解决「养客」</a:t>
             </a:r>
@@ -26278,7 +26278,7 @@
                 <a:solidFill>
                   <a:srgbClr val="1EA06A"/>
                 </a:solidFill>
-                <a:latin typeface="WenQuanYi Micro Hei"/>
+                <a:latin typeface="Microsoft YaHei"/>
               </a:rPr>
               <a:t>▸ </a:t>
             </a:r>
@@ -26287,7 +26287,7 @@
                 <a:solidFill>
                   <a:srgbClr val="222A33"/>
                 </a:solidFill>
-                <a:latin typeface="WenQuanYi Micro Hei"/>
+                <a:latin typeface="Microsoft YaHei"/>
               </a:rPr>
               <a:t>金卡享更高储值赠送比例（充500送80）</a:t>
             </a:r>
@@ -26332,7 +26332,7 @@
                 <a:solidFill>
                   <a:srgbClr val="1EA06A"/>
                 </a:solidFill>
-                <a:latin typeface="WenQuanYi Micro Hei"/>
+                <a:latin typeface="Microsoft YaHei"/>
               </a:rPr>
               <a:t>▸ </a:t>
             </a:r>
@@ -26341,7 +26341,7 @@
                 <a:solidFill>
                   <a:srgbClr val="222A33"/>
                 </a:solidFill>
-                <a:latin typeface="WenQuanYi Micro Hei"/>
+                <a:latin typeface="Microsoft YaHei"/>
               </a:rPr>
               <a:t>沉睡会员自动推券唤醒（30天未到店）</a:t>
             </a:r>
@@ -26386,7 +26386,7 @@
                 <a:solidFill>
                   <a:srgbClr val="1EA06A"/>
                 </a:solidFill>
-                <a:latin typeface="WenQuanYi Micro Hei"/>
+                <a:latin typeface="Microsoft YaHei"/>
               </a:rPr>
               <a:t>▸ </a:t>
             </a:r>
@@ -26395,7 +26395,7 @@
                 <a:solidFill>
                   <a:srgbClr val="222A33"/>
                 </a:solidFill>
-                <a:latin typeface="WenQuanYi Micro Hei"/>
+                <a:latin typeface="Microsoft YaHei"/>
               </a:rPr>
               <a:t>会员消费数据反哺爆款与排班决策</a:t>
             </a:r>
@@ -26440,7 +26440,7 @@
                 <a:solidFill>
                   <a:srgbClr val="AAB2BC"/>
                 </a:solidFill>
-                <a:latin typeface="WenQuanYi Micro Hei"/>
+                <a:latin typeface="Microsoft YaHei"/>
               </a:rPr>
               <a:t>新豪仔小龙虾烧烤融合菜 · 数字化经营解决方案</a:t>
             </a:r>
@@ -26485,7 +26485,7 @@
                 <a:solidFill>
                   <a:srgbClr val="6B7280"/>
                 </a:solidFill>
-                <a:latin typeface="WenQuanYi Micro Hei"/>
+                <a:latin typeface="Microsoft YaHei"/>
               </a:rPr>
               <a:t>08</a:t>
             </a:r>
@@ -26688,7 +26688,7 @@
                 <a:solidFill>
                   <a:srgbClr val="B8CBE0"/>
                 </a:solidFill>
-                <a:latin typeface="WenQuanYi Micro Hei"/>
+                <a:latin typeface="Microsoft YaHei"/>
               </a:rPr>
               <a:t>STORED VALUE · 储值方案</a:t>
             </a:r>
@@ -26733,7 +26733,7 @@
                 <a:solidFill>
                   <a:srgbClr val="FFFFFF"/>
                 </a:solidFill>
-                <a:latin typeface="WenQuanYi Micro Hei"/>
+                <a:latin typeface="Microsoft YaHei"/>
               </a:rPr>
               <a:t>适配¥80客单的「够得着」储值档</a:t>
             </a:r>
@@ -26742,7 +26742,7 @@
                 <a:solidFill>
                   <a:srgbClr val="FFB87A"/>
                 </a:solidFill>
-                <a:latin typeface="WenQuanYi Micro Hei"/>
+                <a:latin typeface="Microsoft YaHei"/>
               </a:rPr>
               <a:t>   开业第2-3周推出</a:t>
             </a:r>
@@ -26787,7 +26787,7 @@
                 <a:solidFill>
                   <a:srgbClr val="222A33"/>
                 </a:solidFill>
-                <a:latin typeface="WenQuanYi Micro Hei"/>
+                <a:latin typeface="Microsoft YaHei"/>
               </a:rPr>
               <a:t>¥80人均的烧烤夜宵店属中客单中频，主推档=客单×3–5次≈¥300，让客人「3-5次用完」，心理负担最小。</a:t>
             </a:r>
@@ -26973,7 +26973,7 @@
                 <a:solidFill>
                   <a:srgbClr val="FFFFFF"/>
                 </a:solidFill>
-                <a:latin typeface="WenQuanYi Micro Hei"/>
+                <a:latin typeface="Microsoft YaHei"/>
               </a:rPr>
               <a:t>体验档</a:t>
             </a:r>
@@ -27018,7 +27018,7 @@
                 <a:solidFill>
                   <a:srgbClr val="122A4A"/>
                 </a:solidFill>
-                <a:latin typeface="WenQuanYi Micro Hei"/>
+                <a:latin typeface="Microsoft YaHei"/>
               </a:rPr>
               <a:t>充200</a:t>
             </a:r>
@@ -27063,7 +27063,7 @@
                 <a:solidFill>
                   <a:srgbClr val="6B7280"/>
                 </a:solidFill>
-                <a:latin typeface="WenQuanYi Micro Hei"/>
+                <a:latin typeface="Microsoft YaHei"/>
               </a:rPr>
               <a:t>送20  (约9.1折)</a:t>
             </a:r>
@@ -27152,7 +27152,7 @@
                 <a:solidFill>
                   <a:srgbClr val="222A33"/>
                 </a:solidFill>
-                <a:latin typeface="WenQuanYi Micro Hei"/>
+                <a:latin typeface="Microsoft YaHei"/>
               </a:rPr>
               <a:t>试水门槛，开业首周限时</a:t>
             </a:r>
@@ -27338,7 +27338,7 @@
                 <a:solidFill>
                   <a:srgbClr val="FFFFFF"/>
                 </a:solidFill>
-                <a:latin typeface="WenQuanYi Micro Hei"/>
+                <a:latin typeface="Microsoft YaHei"/>
               </a:rPr>
               <a:t>⭐ 主推档 主推</a:t>
             </a:r>
@@ -27383,7 +27383,7 @@
                 <a:solidFill>
                   <a:srgbClr val="FF6D00"/>
                 </a:solidFill>
-                <a:latin typeface="WenQuanYi Micro Hei"/>
+                <a:latin typeface="Microsoft YaHei"/>
               </a:rPr>
               <a:t>充300</a:t>
             </a:r>
@@ -27428,7 +27428,7 @@
                 <a:solidFill>
                   <a:srgbClr val="FF6D00"/>
                 </a:solidFill>
-                <a:latin typeface="WenQuanYi Micro Hei"/>
+                <a:latin typeface="Microsoft YaHei"/>
               </a:rPr>
               <a:t>送50  (约8.6折)</a:t>
             </a:r>
@@ -27517,7 +27517,7 @@
                 <a:solidFill>
                   <a:srgbClr val="222A33"/>
                 </a:solidFill>
-                <a:latin typeface="WenQuanYi Micro Hei"/>
+                <a:latin typeface="Microsoft YaHei"/>
               </a:rPr>
               <a:t>≈4次消费用完，转化最高</a:t>
             </a:r>
@@ -27703,7 +27703,7 @@
                 <a:solidFill>
                   <a:srgbClr val="FFFFFF"/>
                 </a:solidFill>
-                <a:latin typeface="WenQuanYi Micro Hei"/>
+                <a:latin typeface="Microsoft YaHei"/>
               </a:rPr>
               <a:t>尊享档</a:t>
             </a:r>
@@ -27748,7 +27748,7 @@
                 <a:solidFill>
                   <a:srgbClr val="122A4A"/>
                 </a:solidFill>
-                <a:latin typeface="WenQuanYi Micro Hei"/>
+                <a:latin typeface="Microsoft YaHei"/>
               </a:rPr>
               <a:t>充500</a:t>
             </a:r>
@@ -27793,7 +27793,7 @@
                 <a:solidFill>
                   <a:srgbClr val="6B7280"/>
                 </a:solidFill>
-                <a:latin typeface="WenQuanYi Micro Hei"/>
+                <a:latin typeface="Microsoft YaHei"/>
               </a:rPr>
               <a:t>送100  (约8.3折)</a:t>
             </a:r>
@@ -27882,7 +27882,7 @@
                 <a:solidFill>
                   <a:srgbClr val="222A33"/>
                 </a:solidFill>
-                <a:latin typeface="WenQuanYi Micro Hei"/>
+                <a:latin typeface="Microsoft YaHei"/>
               </a:rPr>
               <a:t>赠金+升金卡，绑定高频客</a:t>
             </a:r>
@@ -27971,7 +27971,7 @@
                 <a:solidFill>
                   <a:srgbClr val="FF6D00"/>
                 </a:solidFill>
-                <a:latin typeface="WenQuanYi Micro Hei"/>
+                <a:latin typeface="Microsoft YaHei"/>
               </a:rPr>
               <a:t>📌 收银台话术：</a:t>
             </a:r>
@@ -27980,7 +27980,7 @@
                 <a:solidFill>
                   <a:srgbClr val="222A33"/>
                 </a:solidFill>
-                <a:latin typeface="WenQuanYi Micro Hei"/>
+                <a:latin typeface="Microsoft YaHei"/>
               </a:rPr>
               <a:t>「您今天消费¥82，充¥300刚好够4次，赠¥50还能升金卡，下次直接刷就行」——结账每桌必问，开口率目标≥80%。</a:t>
             </a:r>
@@ -28025,7 +28025,7 @@
                 <a:solidFill>
                   <a:srgbClr val="AAB2BC"/>
                 </a:solidFill>
-                <a:latin typeface="WenQuanYi Micro Hei"/>
+                <a:latin typeface="Microsoft YaHei"/>
               </a:rPr>
               <a:t>新豪仔小龙虾烧烤融合菜 · 数字化经营解决方案</a:t>
             </a:r>
@@ -28070,7 +28070,7 @@
                 <a:solidFill>
                   <a:srgbClr val="6B7280"/>
                 </a:solidFill>
-                <a:latin typeface="WenQuanYi Micro Hei"/>
+                <a:latin typeface="Microsoft YaHei"/>
               </a:rPr>
               <a:t>09</a:t>
             </a:r>

</xml_diff>